<commit_message>
fix(pptx): row tolerance comparison uses raw top, not the row's anchor
Signed-off-by: Cesar Berrospi Ramis <ceb@zurich.ibm.com>
</commit_message>
<xml_diff>
--- a/tests/data/pptx/sources/powerpoint_visual_order.pptx
+++ b/tests/data/pptx/sources/powerpoint_visual_order.pptx
@@ -5,15 +5,16 @@
     <p:sldMasterId id="2147483648" r:id="rId1"/>
   </p:sldMasterIdLst>
   <p:sldIdLst>
-    <p:sldId id="256" r:id="rId2"/>
+    <p:sldId id="256" r:id="rId7"/>
+    <p:sldId id="257" r:id="rId8"/>
   </p:sldIdLst>
-  <p:sldSz cx="12192000" cy="6858000"/>
+  <p:sldSz cx="9144000" cy="6858000" type="screen4x3"/>
   <p:notesSz cx="6858000" cy="9144000"/>
   <p:defaultTextStyle>
     <a:defPPr>
       <a:defRPr lang="en-US"/>
     </a:defPPr>
-    <a:lvl1pPr marL="0" algn="l" defTabSz="914400" rtl="0" eaLnBrk="1" latinLnBrk="0" hangingPunct="1">
+    <a:lvl1pPr marL="0" algn="l" defTabSz="457200" rtl="0" eaLnBrk="1" latinLnBrk="0" hangingPunct="1">
       <a:defRPr sz="1800" kern="1200">
         <a:solidFill>
           <a:schemeClr val="tx1"/>
@@ -23,7 +24,7 @@
         <a:cs typeface="+mn-cs"/>
       </a:defRPr>
     </a:lvl1pPr>
-    <a:lvl2pPr marL="457200" algn="l" defTabSz="914400" rtl="0" eaLnBrk="1" latinLnBrk="0" hangingPunct="1">
+    <a:lvl2pPr marL="457200" algn="l" defTabSz="457200" rtl="0" eaLnBrk="1" latinLnBrk="0" hangingPunct="1">
       <a:defRPr sz="1800" kern="1200">
         <a:solidFill>
           <a:schemeClr val="tx1"/>
@@ -33,7 +34,7 @@
         <a:cs typeface="+mn-cs"/>
       </a:defRPr>
     </a:lvl2pPr>
-    <a:lvl3pPr marL="914400" algn="l" defTabSz="914400" rtl="0" eaLnBrk="1" latinLnBrk="0" hangingPunct="1">
+    <a:lvl3pPr marL="914400" algn="l" defTabSz="457200" rtl="0" eaLnBrk="1" latinLnBrk="0" hangingPunct="1">
       <a:defRPr sz="1800" kern="1200">
         <a:solidFill>
           <a:schemeClr val="tx1"/>
@@ -43,7 +44,7 @@
         <a:cs typeface="+mn-cs"/>
       </a:defRPr>
     </a:lvl3pPr>
-    <a:lvl4pPr marL="1371600" algn="l" defTabSz="914400" rtl="0" eaLnBrk="1" latinLnBrk="0" hangingPunct="1">
+    <a:lvl4pPr marL="1371600" algn="l" defTabSz="457200" rtl="0" eaLnBrk="1" latinLnBrk="0" hangingPunct="1">
       <a:defRPr sz="1800" kern="1200">
         <a:solidFill>
           <a:schemeClr val="tx1"/>
@@ -53,7 +54,7 @@
         <a:cs typeface="+mn-cs"/>
       </a:defRPr>
     </a:lvl4pPr>
-    <a:lvl5pPr marL="1828800" algn="l" defTabSz="914400" rtl="0" eaLnBrk="1" latinLnBrk="0" hangingPunct="1">
+    <a:lvl5pPr marL="1828800" algn="l" defTabSz="457200" rtl="0" eaLnBrk="1" latinLnBrk="0" hangingPunct="1">
       <a:defRPr sz="1800" kern="1200">
         <a:solidFill>
           <a:schemeClr val="tx1"/>
@@ -63,7 +64,7 @@
         <a:cs typeface="+mn-cs"/>
       </a:defRPr>
     </a:lvl5pPr>
-    <a:lvl6pPr marL="2286000" algn="l" defTabSz="914400" rtl="0" eaLnBrk="1" latinLnBrk="0" hangingPunct="1">
+    <a:lvl6pPr marL="2286000" algn="l" defTabSz="457200" rtl="0" eaLnBrk="1" latinLnBrk="0" hangingPunct="1">
       <a:defRPr sz="1800" kern="1200">
         <a:solidFill>
           <a:schemeClr val="tx1"/>
@@ -73,7 +74,7 @@
         <a:cs typeface="+mn-cs"/>
       </a:defRPr>
     </a:lvl6pPr>
-    <a:lvl7pPr marL="2743200" algn="l" defTabSz="914400" rtl="0" eaLnBrk="1" latinLnBrk="0" hangingPunct="1">
+    <a:lvl7pPr marL="2743200" algn="l" defTabSz="457200" rtl="0" eaLnBrk="1" latinLnBrk="0" hangingPunct="1">
       <a:defRPr sz="1800" kern="1200">
         <a:solidFill>
           <a:schemeClr val="tx1"/>
@@ -83,7 +84,7 @@
         <a:cs typeface="+mn-cs"/>
       </a:defRPr>
     </a:lvl7pPr>
-    <a:lvl8pPr marL="3200400" algn="l" defTabSz="914400" rtl="0" eaLnBrk="1" latinLnBrk="0" hangingPunct="1">
+    <a:lvl8pPr marL="3200400" algn="l" defTabSz="457200" rtl="0" eaLnBrk="1" latinLnBrk="0" hangingPunct="1">
       <a:defRPr sz="1800" kern="1200">
         <a:solidFill>
           <a:schemeClr val="tx1"/>
@@ -93,7 +94,7 @@
         <a:cs typeface="+mn-cs"/>
       </a:defRPr>
     </a:lvl8pPr>
-    <a:lvl9pPr marL="3657600" algn="l" defTabSz="914400" rtl="0" eaLnBrk="1" latinLnBrk="0" hangingPunct="1">
+    <a:lvl9pPr marL="3657600" algn="l" defTabSz="457200" rtl="0" eaLnBrk="1" latinLnBrk="0" hangingPunct="1">
       <a:defRPr sz="1800" kern="1200">
         <a:solidFill>
           <a:schemeClr val="tx1"/>
@@ -104,11 +105,6 @@
       </a:defRPr>
     </a:lvl9pPr>
   </p:defaultTextStyle>
-  <p:extLst>
-    <p:ext uri="{EFAFB233-063F-42B5-8137-9DF3F51BA10A}">
-      <p15:sldGuideLst xmlns:p15="http://schemas.microsoft.com/office/powerpoint/2012/main"/>
-    </p:ext>
-  </p:extLst>
 </p:presentation>
 </file>
 
@@ -131,13 +127,7 @@
       </p:grpSpPr>
       <p:sp>
         <p:nvSpPr>
-          <p:cNvPr id="2" name="Title 1">
-            <a:extLst>
-              <a:ext uri="{FF2B5EF4-FFF2-40B4-BE49-F238E27FC236}">
-                <a16:creationId xmlns:a16="http://schemas.microsoft.com/office/drawing/2014/main" id="{5865E8E6-C37F-6B36-8FBE-B534B6F534BA}"/>
-              </a:ext>
-            </a:extLst>
-          </p:cNvPr>
+          <p:cNvPr id="2" name="Title 1"/>
           <p:cNvSpPr>
             <a:spLocks noGrp="1"/>
           </p:cNvSpPr>
@@ -147,34 +137,25 @@
         </p:nvSpPr>
         <p:spPr>
           <a:xfrm>
-            <a:off x="1524000" y="1122363"/>
-            <a:ext cx="9144000" cy="2387600"/>
+            <a:off x="685800" y="2130425"/>
+            <a:ext cx="7772400" cy="1470025"/>
           </a:xfrm>
         </p:spPr>
         <p:txBody>
-          <a:bodyPr anchor="b"/>
-          <a:lstStyle>
-            <a:lvl1pPr algn="ctr">
-              <a:defRPr sz="6000"/>
-            </a:lvl1pPr>
-          </a:lstStyle>
-          <a:p>
-            <a:r>
-              <a:rPr lang="en-US"/>
+          <a:bodyPr/>
+          <a:lstStyle/>
+          <a:p>
+            <a:r>
+              <a:rPr lang="en-US" smtClean="0"/>
               <a:t>Click to edit Master title style</a:t>
             </a:r>
-          </a:p>
-        </p:txBody>
-      </p:sp>
-      <p:sp>
-        <p:nvSpPr>
-          <p:cNvPr id="3" name="Subtitle 2">
-            <a:extLst>
-              <a:ext uri="{FF2B5EF4-FFF2-40B4-BE49-F238E27FC236}">
-                <a16:creationId xmlns:a16="http://schemas.microsoft.com/office/drawing/2014/main" id="{3064D195-FF46-70F4-586D-715166791A61}"/>
-              </a:ext>
-            </a:extLst>
-          </p:cNvPr>
+            <a:endParaRPr lang="en-US"/>
+          </a:p>
+        </p:txBody>
+      </p:sp>
+      <p:sp>
+        <p:nvSpPr>
+          <p:cNvPr id="3" name="Subtitle 2"/>
           <p:cNvSpPr>
             <a:spLocks noGrp="1"/>
           </p:cNvSpPr>
@@ -184,8 +165,8 @@
         </p:nvSpPr>
         <p:spPr>
           <a:xfrm>
-            <a:off x="1524000" y="3602038"/>
-            <a:ext cx="9144000" cy="1655762"/>
+            <a:off x="1371600" y="3886200"/>
+            <a:ext cx="6400800" cy="1752600"/>
           </a:xfrm>
         </p:spPr>
         <p:txBody>
@@ -193,58 +174,107 @@
           <a:lstStyle>
             <a:lvl1pPr marL="0" indent="0" algn="ctr">
               <a:buNone/>
-              <a:defRPr sz="2400"/>
+              <a:defRPr>
+                <a:solidFill>
+                  <a:schemeClr val="tx1">
+                    <a:tint val="75000"/>
+                  </a:schemeClr>
+                </a:solidFill>
+              </a:defRPr>
             </a:lvl1pPr>
             <a:lvl2pPr marL="457200" indent="0" algn="ctr">
               <a:buNone/>
-              <a:defRPr sz="2000"/>
+              <a:defRPr>
+                <a:solidFill>
+                  <a:schemeClr val="tx1">
+                    <a:tint val="75000"/>
+                  </a:schemeClr>
+                </a:solidFill>
+              </a:defRPr>
             </a:lvl2pPr>
             <a:lvl3pPr marL="914400" indent="0" algn="ctr">
               <a:buNone/>
-              <a:defRPr sz="1800"/>
+              <a:defRPr>
+                <a:solidFill>
+                  <a:schemeClr val="tx1">
+                    <a:tint val="75000"/>
+                  </a:schemeClr>
+                </a:solidFill>
+              </a:defRPr>
             </a:lvl3pPr>
             <a:lvl4pPr marL="1371600" indent="0" algn="ctr">
               <a:buNone/>
-              <a:defRPr sz="1600"/>
+              <a:defRPr>
+                <a:solidFill>
+                  <a:schemeClr val="tx1">
+                    <a:tint val="75000"/>
+                  </a:schemeClr>
+                </a:solidFill>
+              </a:defRPr>
             </a:lvl4pPr>
             <a:lvl5pPr marL="1828800" indent="0" algn="ctr">
               <a:buNone/>
-              <a:defRPr sz="1600"/>
+              <a:defRPr>
+                <a:solidFill>
+                  <a:schemeClr val="tx1">
+                    <a:tint val="75000"/>
+                  </a:schemeClr>
+                </a:solidFill>
+              </a:defRPr>
             </a:lvl5pPr>
             <a:lvl6pPr marL="2286000" indent="0" algn="ctr">
               <a:buNone/>
-              <a:defRPr sz="1600"/>
+              <a:defRPr>
+                <a:solidFill>
+                  <a:schemeClr val="tx1">
+                    <a:tint val="75000"/>
+                  </a:schemeClr>
+                </a:solidFill>
+              </a:defRPr>
             </a:lvl6pPr>
             <a:lvl7pPr marL="2743200" indent="0" algn="ctr">
               <a:buNone/>
-              <a:defRPr sz="1600"/>
+              <a:defRPr>
+                <a:solidFill>
+                  <a:schemeClr val="tx1">
+                    <a:tint val="75000"/>
+                  </a:schemeClr>
+                </a:solidFill>
+              </a:defRPr>
             </a:lvl7pPr>
             <a:lvl8pPr marL="3200400" indent="0" algn="ctr">
               <a:buNone/>
-              <a:defRPr sz="1600"/>
+              <a:defRPr>
+                <a:solidFill>
+                  <a:schemeClr val="tx1">
+                    <a:tint val="75000"/>
+                  </a:schemeClr>
+                </a:solidFill>
+              </a:defRPr>
             </a:lvl8pPr>
             <a:lvl9pPr marL="3657600" indent="0" algn="ctr">
               <a:buNone/>
-              <a:defRPr sz="1600"/>
+              <a:defRPr>
+                <a:solidFill>
+                  <a:schemeClr val="tx1">
+                    <a:tint val="75000"/>
+                  </a:schemeClr>
+                </a:solidFill>
+              </a:defRPr>
             </a:lvl9pPr>
           </a:lstStyle>
           <a:p>
             <a:r>
-              <a:rPr lang="en-US"/>
+              <a:rPr lang="en-US" smtClean="0"/>
               <a:t>Click to edit Master subtitle style</a:t>
             </a:r>
-          </a:p>
-        </p:txBody>
-      </p:sp>
-      <p:sp>
-        <p:nvSpPr>
-          <p:cNvPr id="4" name="Date Placeholder 3">
-            <a:extLst>
-              <a:ext uri="{FF2B5EF4-FFF2-40B4-BE49-F238E27FC236}">
-                <a16:creationId xmlns:a16="http://schemas.microsoft.com/office/drawing/2014/main" id="{143C7080-F960-79C0-D140-E923B6918E3A}"/>
-              </a:ext>
-            </a:extLst>
-          </p:cNvPr>
+            <a:endParaRPr lang="en-US"/>
+          </a:p>
+        </p:txBody>
+      </p:sp>
+      <p:sp>
+        <p:nvSpPr>
+          <p:cNvPr id="4" name="Date Placeholder 3"/>
           <p:cNvSpPr>
             <a:spLocks noGrp="1"/>
           </p:cNvSpPr>
@@ -257,9 +287,9 @@
           <a:bodyPr/>
           <a:lstStyle/>
           <a:p>
-            <a:fld id="{77728346-2AB5-1B41-BB29-9C38D3698713}" type="datetimeFigureOut">
-              <a:rPr lang="en-US" smtClean="0"/>
-              <a:t>11/20/25</a:t>
+            <a:fld id="{5BCAD085-E8A6-8845-BD4E-CB4CCA059FC4}" type="datetimeFigureOut">
+              <a:rPr lang="en-US" smtClean="0"/>
+              <a:t>1/27/13</a:t>
             </a:fld>
             <a:endParaRPr lang="en-US"/>
           </a:p>
@@ -267,13 +297,7 @@
       </p:sp>
       <p:sp>
         <p:nvSpPr>
-          <p:cNvPr id="5" name="Footer Placeholder 4">
-            <a:extLst>
-              <a:ext uri="{FF2B5EF4-FFF2-40B4-BE49-F238E27FC236}">
-                <a16:creationId xmlns:a16="http://schemas.microsoft.com/office/drawing/2014/main" id="{583F21E5-86E7-5A9D-A83B-81F44123BDD7}"/>
-              </a:ext>
-            </a:extLst>
-          </p:cNvPr>
+          <p:cNvPr id="5" name="Footer Placeholder 4"/>
           <p:cNvSpPr>
             <a:spLocks noGrp="1"/>
           </p:cNvSpPr>
@@ -292,13 +316,7 @@
       </p:sp>
       <p:sp>
         <p:nvSpPr>
-          <p:cNvPr id="6" name="Slide Number Placeholder 5">
-            <a:extLst>
-              <a:ext uri="{FF2B5EF4-FFF2-40B4-BE49-F238E27FC236}">
-                <a16:creationId xmlns:a16="http://schemas.microsoft.com/office/drawing/2014/main" id="{5B09ECE1-8FB9-81BF-B206-DBCF7AA8B604}"/>
-              </a:ext>
-            </a:extLst>
-          </p:cNvPr>
+          <p:cNvPr id="6" name="Slide Number Placeholder 5"/>
           <p:cNvSpPr>
             <a:spLocks noGrp="1"/>
           </p:cNvSpPr>
@@ -311,7 +329,7 @@
           <a:bodyPr/>
           <a:lstStyle/>
           <a:p>
-            <a:fld id="{3DE4617C-001E-1047-A50C-4774964ACBA9}" type="slidenum">
+            <a:fld id="{C1FF6DA9-008F-8B48-92A6-B652298478BF}" type="slidenum">
               <a:rPr lang="en-US" smtClean="0"/>
               <a:t>‹#›</a:t>
             </a:fld>
@@ -322,7 +340,7 @@
     </p:spTree>
     <p:extLst>
       <p:ext uri="{BB962C8B-B14F-4D97-AF65-F5344CB8AC3E}">
-        <p14:creationId xmlns:p14="http://schemas.microsoft.com/office/powerpoint/2010/main" val="2177317739"/>
+        <p14:creationId xmlns:p14="http://schemas.microsoft.com/office/powerpoint/2010/main" val="3168075583"/>
       </p:ext>
     </p:extLst>
   </p:cSld>
@@ -351,13 +369,7 @@
       </p:grpSpPr>
       <p:sp>
         <p:nvSpPr>
-          <p:cNvPr id="2" name="Title 1">
-            <a:extLst>
-              <a:ext uri="{FF2B5EF4-FFF2-40B4-BE49-F238E27FC236}">
-                <a16:creationId xmlns:a16="http://schemas.microsoft.com/office/drawing/2014/main" id="{AD13C4A5-079A-59ED-208B-51B9F3F1EF6E}"/>
-              </a:ext>
-            </a:extLst>
-          </p:cNvPr>
+          <p:cNvPr id="2" name="Title 1"/>
           <p:cNvSpPr>
             <a:spLocks noGrp="1"/>
           </p:cNvSpPr>
@@ -371,21 +383,16 @@
           <a:lstStyle/>
           <a:p>
             <a:r>
-              <a:rPr lang="en-US"/>
+              <a:rPr lang="en-US" smtClean="0"/>
               <a:t>Click to edit Master title style</a:t>
             </a:r>
-          </a:p>
-        </p:txBody>
-      </p:sp>
-      <p:sp>
-        <p:nvSpPr>
-          <p:cNvPr id="3" name="Vertical Text Placeholder 2">
-            <a:extLst>
-              <a:ext uri="{FF2B5EF4-FFF2-40B4-BE49-F238E27FC236}">
-                <a16:creationId xmlns:a16="http://schemas.microsoft.com/office/drawing/2014/main" id="{C2C992B7-0589-4555-CA7E-B5DE788E8656}"/>
-              </a:ext>
-            </a:extLst>
-          </p:cNvPr>
+            <a:endParaRPr lang="en-US"/>
+          </a:p>
+        </p:txBody>
+      </p:sp>
+      <p:sp>
+        <p:nvSpPr>
+          <p:cNvPr id="3" name="Vertical Text Placeholder 2"/>
           <p:cNvSpPr>
             <a:spLocks noGrp="1"/>
           </p:cNvSpPr>
@@ -400,49 +407,44 @@
           <a:p>
             <a:pPr lvl="0"/>
             <a:r>
-              <a:rPr lang="en-US"/>
+              <a:rPr lang="en-US" smtClean="0"/>
               <a:t>Click to edit Master text styles</a:t>
             </a:r>
           </a:p>
           <a:p>
             <a:pPr lvl="1"/>
             <a:r>
-              <a:rPr lang="en-US"/>
+              <a:rPr lang="en-US" smtClean="0"/>
               <a:t>Second level</a:t>
             </a:r>
           </a:p>
           <a:p>
             <a:pPr lvl="2"/>
             <a:r>
-              <a:rPr lang="en-US"/>
+              <a:rPr lang="en-US" smtClean="0"/>
               <a:t>Third level</a:t>
             </a:r>
           </a:p>
           <a:p>
             <a:pPr lvl="3"/>
             <a:r>
-              <a:rPr lang="en-US"/>
+              <a:rPr lang="en-US" smtClean="0"/>
               <a:t>Fourth level</a:t>
             </a:r>
           </a:p>
           <a:p>
             <a:pPr lvl="4"/>
             <a:r>
-              <a:rPr lang="en-US"/>
+              <a:rPr lang="en-US" smtClean="0"/>
               <a:t>Fifth level</a:t>
             </a:r>
-          </a:p>
-        </p:txBody>
-      </p:sp>
-      <p:sp>
-        <p:nvSpPr>
-          <p:cNvPr id="4" name="Date Placeholder 3">
-            <a:extLst>
-              <a:ext uri="{FF2B5EF4-FFF2-40B4-BE49-F238E27FC236}">
-                <a16:creationId xmlns:a16="http://schemas.microsoft.com/office/drawing/2014/main" id="{1729969B-3886-8B66-D97E-A55FC62A1853}"/>
-              </a:ext>
-            </a:extLst>
-          </p:cNvPr>
+            <a:endParaRPr lang="en-US"/>
+          </a:p>
+        </p:txBody>
+      </p:sp>
+      <p:sp>
+        <p:nvSpPr>
+          <p:cNvPr id="4" name="Date Placeholder 3"/>
           <p:cNvSpPr>
             <a:spLocks noGrp="1"/>
           </p:cNvSpPr>
@@ -455,9 +457,9 @@
           <a:bodyPr/>
           <a:lstStyle/>
           <a:p>
-            <a:fld id="{77728346-2AB5-1B41-BB29-9C38D3698713}" type="datetimeFigureOut">
-              <a:rPr lang="en-US" smtClean="0"/>
-              <a:t>11/20/25</a:t>
+            <a:fld id="{5BCAD085-E8A6-8845-BD4E-CB4CCA059FC4}" type="datetimeFigureOut">
+              <a:rPr lang="en-US" smtClean="0"/>
+              <a:t>1/27/13</a:t>
             </a:fld>
             <a:endParaRPr lang="en-US"/>
           </a:p>
@@ -465,13 +467,7 @@
       </p:sp>
       <p:sp>
         <p:nvSpPr>
-          <p:cNvPr id="5" name="Footer Placeholder 4">
-            <a:extLst>
-              <a:ext uri="{FF2B5EF4-FFF2-40B4-BE49-F238E27FC236}">
-                <a16:creationId xmlns:a16="http://schemas.microsoft.com/office/drawing/2014/main" id="{BE7E5AC9-A701-DF42-4266-3C8BB015735E}"/>
-              </a:ext>
-            </a:extLst>
-          </p:cNvPr>
+          <p:cNvPr id="5" name="Footer Placeholder 4"/>
           <p:cNvSpPr>
             <a:spLocks noGrp="1"/>
           </p:cNvSpPr>
@@ -490,13 +486,7 @@
       </p:sp>
       <p:sp>
         <p:nvSpPr>
-          <p:cNvPr id="6" name="Slide Number Placeholder 5">
-            <a:extLst>
-              <a:ext uri="{FF2B5EF4-FFF2-40B4-BE49-F238E27FC236}">
-                <a16:creationId xmlns:a16="http://schemas.microsoft.com/office/drawing/2014/main" id="{E4F72BA0-B473-2EA3-FB28-BFF46CC7C1F4}"/>
-              </a:ext>
-            </a:extLst>
-          </p:cNvPr>
+          <p:cNvPr id="6" name="Slide Number Placeholder 5"/>
           <p:cNvSpPr>
             <a:spLocks noGrp="1"/>
           </p:cNvSpPr>
@@ -509,7 +499,7 @@
           <a:bodyPr/>
           <a:lstStyle/>
           <a:p>
-            <a:fld id="{3DE4617C-001E-1047-A50C-4774964ACBA9}" type="slidenum">
+            <a:fld id="{C1FF6DA9-008F-8B48-92A6-B652298478BF}" type="slidenum">
               <a:rPr lang="en-US" smtClean="0"/>
               <a:t>‹#›</a:t>
             </a:fld>
@@ -520,7 +510,7 @@
     </p:spTree>
     <p:extLst>
       <p:ext uri="{BB962C8B-B14F-4D97-AF65-F5344CB8AC3E}">
-        <p14:creationId xmlns:p14="http://schemas.microsoft.com/office/powerpoint/2010/main" val="1772584264"/>
+        <p14:creationId xmlns:p14="http://schemas.microsoft.com/office/powerpoint/2010/main" val="2910927964"/>
       </p:ext>
     </p:extLst>
   </p:cSld>
@@ -549,13 +539,7 @@
       </p:grpSpPr>
       <p:sp>
         <p:nvSpPr>
-          <p:cNvPr id="2" name="Vertical Title 1">
-            <a:extLst>
-              <a:ext uri="{FF2B5EF4-FFF2-40B4-BE49-F238E27FC236}">
-                <a16:creationId xmlns:a16="http://schemas.microsoft.com/office/drawing/2014/main" id="{74EEC380-B44D-A1E1-EEA0-329289605786}"/>
-              </a:ext>
-            </a:extLst>
-          </p:cNvPr>
+          <p:cNvPr id="2" name="Vertical Title 1"/>
           <p:cNvSpPr>
             <a:spLocks noGrp="1"/>
           </p:cNvSpPr>
@@ -565,8 +549,8 @@
         </p:nvSpPr>
         <p:spPr>
           <a:xfrm>
-            <a:off x="8724900" y="365125"/>
-            <a:ext cx="2628900" cy="5811838"/>
+            <a:off x="6629400" y="274638"/>
+            <a:ext cx="2057400" cy="5851525"/>
           </a:xfrm>
         </p:spPr>
         <p:txBody>
@@ -574,21 +558,16 @@
           <a:lstStyle/>
           <a:p>
             <a:r>
-              <a:rPr lang="en-US"/>
+              <a:rPr lang="en-US" smtClean="0"/>
               <a:t>Click to edit Master title style</a:t>
             </a:r>
-          </a:p>
-        </p:txBody>
-      </p:sp>
-      <p:sp>
-        <p:nvSpPr>
-          <p:cNvPr id="3" name="Vertical Text Placeholder 2">
-            <a:extLst>
-              <a:ext uri="{FF2B5EF4-FFF2-40B4-BE49-F238E27FC236}">
-                <a16:creationId xmlns:a16="http://schemas.microsoft.com/office/drawing/2014/main" id="{99384714-215E-5F72-C8D4-6EA459C6BF82}"/>
-              </a:ext>
-            </a:extLst>
-          </p:cNvPr>
+            <a:endParaRPr lang="en-US"/>
+          </a:p>
+        </p:txBody>
+      </p:sp>
+      <p:sp>
+        <p:nvSpPr>
+          <p:cNvPr id="3" name="Vertical Text Placeholder 2"/>
           <p:cNvSpPr>
             <a:spLocks noGrp="1"/>
           </p:cNvSpPr>
@@ -598,8 +577,8 @@
         </p:nvSpPr>
         <p:spPr>
           <a:xfrm>
-            <a:off x="838200" y="365125"/>
-            <a:ext cx="7734300" cy="5811838"/>
+            <a:off x="457200" y="274638"/>
+            <a:ext cx="6019800" cy="5851525"/>
           </a:xfrm>
         </p:spPr>
         <p:txBody>
@@ -608,49 +587,44 @@
           <a:p>
             <a:pPr lvl="0"/>
             <a:r>
-              <a:rPr lang="en-US"/>
+              <a:rPr lang="en-US" smtClean="0"/>
               <a:t>Click to edit Master text styles</a:t>
             </a:r>
           </a:p>
           <a:p>
             <a:pPr lvl="1"/>
             <a:r>
-              <a:rPr lang="en-US"/>
+              <a:rPr lang="en-US" smtClean="0"/>
               <a:t>Second level</a:t>
             </a:r>
           </a:p>
           <a:p>
             <a:pPr lvl="2"/>
             <a:r>
-              <a:rPr lang="en-US"/>
+              <a:rPr lang="en-US" smtClean="0"/>
               <a:t>Third level</a:t>
             </a:r>
           </a:p>
           <a:p>
             <a:pPr lvl="3"/>
             <a:r>
-              <a:rPr lang="en-US"/>
+              <a:rPr lang="en-US" smtClean="0"/>
               <a:t>Fourth level</a:t>
             </a:r>
           </a:p>
           <a:p>
             <a:pPr lvl="4"/>
             <a:r>
-              <a:rPr lang="en-US"/>
+              <a:rPr lang="en-US" smtClean="0"/>
               <a:t>Fifth level</a:t>
             </a:r>
-          </a:p>
-        </p:txBody>
-      </p:sp>
-      <p:sp>
-        <p:nvSpPr>
-          <p:cNvPr id="4" name="Date Placeholder 3">
-            <a:extLst>
-              <a:ext uri="{FF2B5EF4-FFF2-40B4-BE49-F238E27FC236}">
-                <a16:creationId xmlns:a16="http://schemas.microsoft.com/office/drawing/2014/main" id="{80E534F0-E525-6387-FA62-C99A934EFAE1}"/>
-              </a:ext>
-            </a:extLst>
-          </p:cNvPr>
+            <a:endParaRPr lang="en-US"/>
+          </a:p>
+        </p:txBody>
+      </p:sp>
+      <p:sp>
+        <p:nvSpPr>
+          <p:cNvPr id="4" name="Date Placeholder 3"/>
           <p:cNvSpPr>
             <a:spLocks noGrp="1"/>
           </p:cNvSpPr>
@@ -663,9 +637,9 @@
           <a:bodyPr/>
           <a:lstStyle/>
           <a:p>
-            <a:fld id="{77728346-2AB5-1B41-BB29-9C38D3698713}" type="datetimeFigureOut">
-              <a:rPr lang="en-US" smtClean="0"/>
-              <a:t>11/20/25</a:t>
+            <a:fld id="{5BCAD085-E8A6-8845-BD4E-CB4CCA059FC4}" type="datetimeFigureOut">
+              <a:rPr lang="en-US" smtClean="0"/>
+              <a:t>1/27/13</a:t>
             </a:fld>
             <a:endParaRPr lang="en-US"/>
           </a:p>
@@ -673,13 +647,7 @@
       </p:sp>
       <p:sp>
         <p:nvSpPr>
-          <p:cNvPr id="5" name="Footer Placeholder 4">
-            <a:extLst>
-              <a:ext uri="{FF2B5EF4-FFF2-40B4-BE49-F238E27FC236}">
-                <a16:creationId xmlns:a16="http://schemas.microsoft.com/office/drawing/2014/main" id="{8BD6C2C3-BA2F-A72E-F332-C0E752288259}"/>
-              </a:ext>
-            </a:extLst>
-          </p:cNvPr>
+          <p:cNvPr id="5" name="Footer Placeholder 4"/>
           <p:cNvSpPr>
             <a:spLocks noGrp="1"/>
           </p:cNvSpPr>
@@ -698,13 +666,7 @@
       </p:sp>
       <p:sp>
         <p:nvSpPr>
-          <p:cNvPr id="6" name="Slide Number Placeholder 5">
-            <a:extLst>
-              <a:ext uri="{FF2B5EF4-FFF2-40B4-BE49-F238E27FC236}">
-                <a16:creationId xmlns:a16="http://schemas.microsoft.com/office/drawing/2014/main" id="{89495996-B8FB-6FFA-A278-F7E024A48120}"/>
-              </a:ext>
-            </a:extLst>
-          </p:cNvPr>
+          <p:cNvPr id="6" name="Slide Number Placeholder 5"/>
           <p:cNvSpPr>
             <a:spLocks noGrp="1"/>
           </p:cNvSpPr>
@@ -717,7 +679,7 @@
           <a:bodyPr/>
           <a:lstStyle/>
           <a:p>
-            <a:fld id="{3DE4617C-001E-1047-A50C-4774964ACBA9}" type="slidenum">
+            <a:fld id="{C1FF6DA9-008F-8B48-92A6-B652298478BF}" type="slidenum">
               <a:rPr lang="en-US" smtClean="0"/>
               <a:t>‹#›</a:t>
             </a:fld>
@@ -728,7 +690,7 @@
     </p:spTree>
     <p:extLst>
       <p:ext uri="{BB962C8B-B14F-4D97-AF65-F5344CB8AC3E}">
-        <p14:creationId xmlns:p14="http://schemas.microsoft.com/office/powerpoint/2010/main" val="1420359303"/>
+        <p14:creationId xmlns:p14="http://schemas.microsoft.com/office/powerpoint/2010/main" val="3612223792"/>
       </p:ext>
     </p:extLst>
   </p:cSld>
@@ -757,13 +719,7 @@
       </p:grpSpPr>
       <p:sp>
         <p:nvSpPr>
-          <p:cNvPr id="2" name="Title 1">
-            <a:extLst>
-              <a:ext uri="{FF2B5EF4-FFF2-40B4-BE49-F238E27FC236}">
-                <a16:creationId xmlns:a16="http://schemas.microsoft.com/office/drawing/2014/main" id="{3C5EEC07-E6C3-0AD7-1089-0CC66F0809E9}"/>
-              </a:ext>
-            </a:extLst>
-          </p:cNvPr>
+          <p:cNvPr id="2" name="Title 1"/>
           <p:cNvSpPr>
             <a:spLocks noGrp="1"/>
           </p:cNvSpPr>
@@ -777,21 +733,16 @@
           <a:lstStyle/>
           <a:p>
             <a:r>
-              <a:rPr lang="en-US"/>
+              <a:rPr lang="en-US" smtClean="0"/>
               <a:t>Click to edit Master title style</a:t>
             </a:r>
-          </a:p>
-        </p:txBody>
-      </p:sp>
-      <p:sp>
-        <p:nvSpPr>
-          <p:cNvPr id="3" name="Content Placeholder 2">
-            <a:extLst>
-              <a:ext uri="{FF2B5EF4-FFF2-40B4-BE49-F238E27FC236}">
-                <a16:creationId xmlns:a16="http://schemas.microsoft.com/office/drawing/2014/main" id="{9408CAB2-6B8A-A5CD-15FA-415CB13E39ED}"/>
-              </a:ext>
-            </a:extLst>
-          </p:cNvPr>
+            <a:endParaRPr lang="en-US"/>
+          </a:p>
+        </p:txBody>
+      </p:sp>
+      <p:sp>
+        <p:nvSpPr>
+          <p:cNvPr id="3" name="Content Placeholder 2"/>
           <p:cNvSpPr>
             <a:spLocks noGrp="1"/>
           </p:cNvSpPr>
@@ -806,49 +757,44 @@
           <a:p>
             <a:pPr lvl="0"/>
             <a:r>
-              <a:rPr lang="en-US"/>
+              <a:rPr lang="en-US" smtClean="0"/>
               <a:t>Click to edit Master text styles</a:t>
             </a:r>
           </a:p>
           <a:p>
             <a:pPr lvl="1"/>
             <a:r>
-              <a:rPr lang="en-US"/>
+              <a:rPr lang="en-US" smtClean="0"/>
               <a:t>Second level</a:t>
             </a:r>
           </a:p>
           <a:p>
             <a:pPr lvl="2"/>
             <a:r>
-              <a:rPr lang="en-US"/>
+              <a:rPr lang="en-US" smtClean="0"/>
               <a:t>Third level</a:t>
             </a:r>
           </a:p>
           <a:p>
             <a:pPr lvl="3"/>
             <a:r>
-              <a:rPr lang="en-US"/>
+              <a:rPr lang="en-US" smtClean="0"/>
               <a:t>Fourth level</a:t>
             </a:r>
           </a:p>
           <a:p>
             <a:pPr lvl="4"/>
             <a:r>
-              <a:rPr lang="en-US"/>
+              <a:rPr lang="en-US" smtClean="0"/>
               <a:t>Fifth level</a:t>
             </a:r>
-          </a:p>
-        </p:txBody>
-      </p:sp>
-      <p:sp>
-        <p:nvSpPr>
-          <p:cNvPr id="4" name="Date Placeholder 3">
-            <a:extLst>
-              <a:ext uri="{FF2B5EF4-FFF2-40B4-BE49-F238E27FC236}">
-                <a16:creationId xmlns:a16="http://schemas.microsoft.com/office/drawing/2014/main" id="{C463E6D2-8724-0D30-21E3-AAE57FE56D65}"/>
-              </a:ext>
-            </a:extLst>
-          </p:cNvPr>
+            <a:endParaRPr lang="en-US"/>
+          </a:p>
+        </p:txBody>
+      </p:sp>
+      <p:sp>
+        <p:nvSpPr>
+          <p:cNvPr id="4" name="Date Placeholder 3"/>
           <p:cNvSpPr>
             <a:spLocks noGrp="1"/>
           </p:cNvSpPr>
@@ -861,9 +807,9 @@
           <a:bodyPr/>
           <a:lstStyle/>
           <a:p>
-            <a:fld id="{77728346-2AB5-1B41-BB29-9C38D3698713}" type="datetimeFigureOut">
-              <a:rPr lang="en-US" smtClean="0"/>
-              <a:t>11/20/25</a:t>
+            <a:fld id="{5BCAD085-E8A6-8845-BD4E-CB4CCA059FC4}" type="datetimeFigureOut">
+              <a:rPr lang="en-US" smtClean="0"/>
+              <a:t>1/27/13</a:t>
             </a:fld>
             <a:endParaRPr lang="en-US"/>
           </a:p>
@@ -871,13 +817,7 @@
       </p:sp>
       <p:sp>
         <p:nvSpPr>
-          <p:cNvPr id="5" name="Footer Placeholder 4">
-            <a:extLst>
-              <a:ext uri="{FF2B5EF4-FFF2-40B4-BE49-F238E27FC236}">
-                <a16:creationId xmlns:a16="http://schemas.microsoft.com/office/drawing/2014/main" id="{880365F1-BE68-83BF-FF34-7E1BA4239B3E}"/>
-              </a:ext>
-            </a:extLst>
-          </p:cNvPr>
+          <p:cNvPr id="5" name="Footer Placeholder 4"/>
           <p:cNvSpPr>
             <a:spLocks noGrp="1"/>
           </p:cNvSpPr>
@@ -896,13 +836,7 @@
       </p:sp>
       <p:sp>
         <p:nvSpPr>
-          <p:cNvPr id="6" name="Slide Number Placeholder 5">
-            <a:extLst>
-              <a:ext uri="{FF2B5EF4-FFF2-40B4-BE49-F238E27FC236}">
-                <a16:creationId xmlns:a16="http://schemas.microsoft.com/office/drawing/2014/main" id="{B469D249-C310-555B-E5B4-7A3858DC4314}"/>
-              </a:ext>
-            </a:extLst>
-          </p:cNvPr>
+          <p:cNvPr id="6" name="Slide Number Placeholder 5"/>
           <p:cNvSpPr>
             <a:spLocks noGrp="1"/>
           </p:cNvSpPr>
@@ -915,7 +849,7 @@
           <a:bodyPr/>
           <a:lstStyle/>
           <a:p>
-            <a:fld id="{3DE4617C-001E-1047-A50C-4774964ACBA9}" type="slidenum">
+            <a:fld id="{C1FF6DA9-008F-8B48-92A6-B652298478BF}" type="slidenum">
               <a:rPr lang="en-US" smtClean="0"/>
               <a:t>‹#›</a:t>
             </a:fld>
@@ -926,7 +860,7 @@
     </p:spTree>
     <p:extLst>
       <p:ext uri="{BB962C8B-B14F-4D97-AF65-F5344CB8AC3E}">
-        <p14:creationId xmlns:p14="http://schemas.microsoft.com/office/powerpoint/2010/main" val="2289376415"/>
+        <p14:creationId xmlns:p14="http://schemas.microsoft.com/office/powerpoint/2010/main" val="2614314258"/>
       </p:ext>
     </p:extLst>
   </p:cSld>
@@ -955,13 +889,7 @@
       </p:grpSpPr>
       <p:sp>
         <p:nvSpPr>
-          <p:cNvPr id="2" name="Title 1">
-            <a:extLst>
-              <a:ext uri="{FF2B5EF4-FFF2-40B4-BE49-F238E27FC236}">
-                <a16:creationId xmlns:a16="http://schemas.microsoft.com/office/drawing/2014/main" id="{1C19ED06-3979-F41E-263C-FB2F83BEA48F}"/>
-              </a:ext>
-            </a:extLst>
-          </p:cNvPr>
+          <p:cNvPr id="2" name="Title 1"/>
           <p:cNvSpPr>
             <a:spLocks noGrp="1"/>
           </p:cNvSpPr>
@@ -971,136 +899,131 @@
         </p:nvSpPr>
         <p:spPr>
           <a:xfrm>
-            <a:off x="831850" y="1709738"/>
-            <a:ext cx="10515600" cy="2852737"/>
+            <a:off x="722313" y="4406900"/>
+            <a:ext cx="7772400" cy="1362075"/>
           </a:xfrm>
         </p:spPr>
         <p:txBody>
+          <a:bodyPr anchor="t"/>
+          <a:lstStyle>
+            <a:lvl1pPr algn="l">
+              <a:defRPr sz="4000" b="1" cap="all"/>
+            </a:lvl1pPr>
+          </a:lstStyle>
+          <a:p>
+            <a:r>
+              <a:rPr lang="en-US" smtClean="0"/>
+              <a:t>Click to edit Master title style</a:t>
+            </a:r>
+            <a:endParaRPr lang="en-US"/>
+          </a:p>
+        </p:txBody>
+      </p:sp>
+      <p:sp>
+        <p:nvSpPr>
+          <p:cNvPr id="3" name="Text Placeholder 2"/>
+          <p:cNvSpPr>
+            <a:spLocks noGrp="1"/>
+          </p:cNvSpPr>
+          <p:nvPr>
+            <p:ph type="body" idx="1"/>
+          </p:nvPr>
+        </p:nvSpPr>
+        <p:spPr>
+          <a:xfrm>
+            <a:off x="722313" y="2906713"/>
+            <a:ext cx="7772400" cy="1500187"/>
+          </a:xfrm>
+        </p:spPr>
+        <p:txBody>
           <a:bodyPr anchor="b"/>
           <a:lstStyle>
-            <a:lvl1pPr>
-              <a:defRPr sz="6000"/>
-            </a:lvl1pPr>
-          </a:lstStyle>
-          <a:p>
-            <a:r>
-              <a:rPr lang="en-US"/>
-              <a:t>Click to edit Master title style</a:t>
-            </a:r>
-          </a:p>
-        </p:txBody>
-      </p:sp>
-      <p:sp>
-        <p:nvSpPr>
-          <p:cNvPr id="3" name="Text Placeholder 2">
-            <a:extLst>
-              <a:ext uri="{FF2B5EF4-FFF2-40B4-BE49-F238E27FC236}">
-                <a16:creationId xmlns:a16="http://schemas.microsoft.com/office/drawing/2014/main" id="{9CBBBC2E-A4BF-2C47-A263-01A635C6D9E3}"/>
-              </a:ext>
-            </a:extLst>
-          </p:cNvPr>
-          <p:cNvSpPr>
-            <a:spLocks noGrp="1"/>
-          </p:cNvSpPr>
-          <p:nvPr>
-            <p:ph type="body" idx="1"/>
-          </p:nvPr>
-        </p:nvSpPr>
-        <p:spPr>
-          <a:xfrm>
-            <a:off x="831850" y="4589463"/>
-            <a:ext cx="10515600" cy="1500187"/>
-          </a:xfrm>
-        </p:spPr>
-        <p:txBody>
-          <a:bodyPr/>
-          <a:lstStyle>
             <a:lvl1pPr marL="0" indent="0">
               <a:buNone/>
-              <a:defRPr sz="2400">
+              <a:defRPr sz="2000">
                 <a:solidFill>
                   <a:schemeClr val="tx1">
-                    <a:tint val="82000"/>
+                    <a:tint val="75000"/>
                   </a:schemeClr>
                 </a:solidFill>
               </a:defRPr>
             </a:lvl1pPr>
             <a:lvl2pPr marL="457200" indent="0">
               <a:buNone/>
-              <a:defRPr sz="2000">
+              <a:defRPr sz="1800">
                 <a:solidFill>
                   <a:schemeClr val="tx1">
-                    <a:tint val="82000"/>
+                    <a:tint val="75000"/>
                   </a:schemeClr>
                 </a:solidFill>
               </a:defRPr>
             </a:lvl2pPr>
             <a:lvl3pPr marL="914400" indent="0">
               <a:buNone/>
-              <a:defRPr sz="1800">
+              <a:defRPr sz="1600">
                 <a:solidFill>
                   <a:schemeClr val="tx1">
-                    <a:tint val="82000"/>
+                    <a:tint val="75000"/>
                   </a:schemeClr>
                 </a:solidFill>
               </a:defRPr>
             </a:lvl3pPr>
             <a:lvl4pPr marL="1371600" indent="0">
               <a:buNone/>
-              <a:defRPr sz="1600">
+              <a:defRPr sz="1400">
                 <a:solidFill>
                   <a:schemeClr val="tx1">
-                    <a:tint val="82000"/>
+                    <a:tint val="75000"/>
                   </a:schemeClr>
                 </a:solidFill>
               </a:defRPr>
             </a:lvl4pPr>
             <a:lvl5pPr marL="1828800" indent="0">
               <a:buNone/>
-              <a:defRPr sz="1600">
+              <a:defRPr sz="1400">
                 <a:solidFill>
                   <a:schemeClr val="tx1">
-                    <a:tint val="82000"/>
+                    <a:tint val="75000"/>
                   </a:schemeClr>
                 </a:solidFill>
               </a:defRPr>
             </a:lvl5pPr>
             <a:lvl6pPr marL="2286000" indent="0">
               <a:buNone/>
-              <a:defRPr sz="1600">
+              <a:defRPr sz="1400">
                 <a:solidFill>
                   <a:schemeClr val="tx1">
-                    <a:tint val="82000"/>
+                    <a:tint val="75000"/>
                   </a:schemeClr>
                 </a:solidFill>
               </a:defRPr>
             </a:lvl6pPr>
             <a:lvl7pPr marL="2743200" indent="0">
               <a:buNone/>
-              <a:defRPr sz="1600">
+              <a:defRPr sz="1400">
                 <a:solidFill>
                   <a:schemeClr val="tx1">
-                    <a:tint val="82000"/>
+                    <a:tint val="75000"/>
                   </a:schemeClr>
                 </a:solidFill>
               </a:defRPr>
             </a:lvl7pPr>
             <a:lvl8pPr marL="3200400" indent="0">
               <a:buNone/>
-              <a:defRPr sz="1600">
+              <a:defRPr sz="1400">
                 <a:solidFill>
                   <a:schemeClr val="tx1">
-                    <a:tint val="82000"/>
+                    <a:tint val="75000"/>
                   </a:schemeClr>
                 </a:solidFill>
               </a:defRPr>
             </a:lvl8pPr>
             <a:lvl9pPr marL="3657600" indent="0">
               <a:buNone/>
-              <a:defRPr sz="1600">
+              <a:defRPr sz="1400">
                 <a:solidFill>
                   <a:schemeClr val="tx1">
-                    <a:tint val="82000"/>
+                    <a:tint val="75000"/>
                   </a:schemeClr>
                 </a:solidFill>
               </a:defRPr>
@@ -1109,7 +1032,7 @@
           <a:p>
             <a:pPr lvl="0"/>
             <a:r>
-              <a:rPr lang="en-US"/>
+              <a:rPr lang="en-US" smtClean="0"/>
               <a:t>Click to edit Master text styles</a:t>
             </a:r>
           </a:p>
@@ -1117,13 +1040,7 @@
       </p:sp>
       <p:sp>
         <p:nvSpPr>
-          <p:cNvPr id="4" name="Date Placeholder 3">
-            <a:extLst>
-              <a:ext uri="{FF2B5EF4-FFF2-40B4-BE49-F238E27FC236}">
-                <a16:creationId xmlns:a16="http://schemas.microsoft.com/office/drawing/2014/main" id="{3978321D-1C42-DF21-261B-A85768F86E6B}"/>
-              </a:ext>
-            </a:extLst>
-          </p:cNvPr>
+          <p:cNvPr id="4" name="Date Placeholder 3"/>
           <p:cNvSpPr>
             <a:spLocks noGrp="1"/>
           </p:cNvSpPr>
@@ -1136,9 +1053,9 @@
           <a:bodyPr/>
           <a:lstStyle/>
           <a:p>
-            <a:fld id="{77728346-2AB5-1B41-BB29-9C38D3698713}" type="datetimeFigureOut">
-              <a:rPr lang="en-US" smtClean="0"/>
-              <a:t>11/20/25</a:t>
+            <a:fld id="{5BCAD085-E8A6-8845-BD4E-CB4CCA059FC4}" type="datetimeFigureOut">
+              <a:rPr lang="en-US" smtClean="0"/>
+              <a:t>1/27/13</a:t>
             </a:fld>
             <a:endParaRPr lang="en-US"/>
           </a:p>
@@ -1146,13 +1063,7 @@
       </p:sp>
       <p:sp>
         <p:nvSpPr>
-          <p:cNvPr id="5" name="Footer Placeholder 4">
-            <a:extLst>
-              <a:ext uri="{FF2B5EF4-FFF2-40B4-BE49-F238E27FC236}">
-                <a16:creationId xmlns:a16="http://schemas.microsoft.com/office/drawing/2014/main" id="{DE7930D0-25A8-9EAB-A5EC-C7E5DFBD05B9}"/>
-              </a:ext>
-            </a:extLst>
-          </p:cNvPr>
+          <p:cNvPr id="5" name="Footer Placeholder 4"/>
           <p:cNvSpPr>
             <a:spLocks noGrp="1"/>
           </p:cNvSpPr>
@@ -1171,13 +1082,7 @@
       </p:sp>
       <p:sp>
         <p:nvSpPr>
-          <p:cNvPr id="6" name="Slide Number Placeholder 5">
-            <a:extLst>
-              <a:ext uri="{FF2B5EF4-FFF2-40B4-BE49-F238E27FC236}">
-                <a16:creationId xmlns:a16="http://schemas.microsoft.com/office/drawing/2014/main" id="{F358B673-E63F-A482-11FA-01453E6B2FC3}"/>
-              </a:ext>
-            </a:extLst>
-          </p:cNvPr>
+          <p:cNvPr id="6" name="Slide Number Placeholder 5"/>
           <p:cNvSpPr>
             <a:spLocks noGrp="1"/>
           </p:cNvSpPr>
@@ -1190,7 +1095,7 @@
           <a:bodyPr/>
           <a:lstStyle/>
           <a:p>
-            <a:fld id="{3DE4617C-001E-1047-A50C-4774964ACBA9}" type="slidenum">
+            <a:fld id="{C1FF6DA9-008F-8B48-92A6-B652298478BF}" type="slidenum">
               <a:rPr lang="en-US" smtClean="0"/>
               <a:t>‹#›</a:t>
             </a:fld>
@@ -1201,7 +1106,7 @@
     </p:spTree>
     <p:extLst>
       <p:ext uri="{BB962C8B-B14F-4D97-AF65-F5344CB8AC3E}">
-        <p14:creationId xmlns:p14="http://schemas.microsoft.com/office/powerpoint/2010/main" val="3416489751"/>
+        <p14:creationId xmlns:p14="http://schemas.microsoft.com/office/powerpoint/2010/main" val="960648375"/>
       </p:ext>
     </p:extLst>
   </p:cSld>
@@ -1230,13 +1135,7 @@
       </p:grpSpPr>
       <p:sp>
         <p:nvSpPr>
-          <p:cNvPr id="2" name="Title 1">
-            <a:extLst>
-              <a:ext uri="{FF2B5EF4-FFF2-40B4-BE49-F238E27FC236}">
-                <a16:creationId xmlns:a16="http://schemas.microsoft.com/office/drawing/2014/main" id="{EA9759C4-2058-0371-776F-DBE4BC199598}"/>
-              </a:ext>
-            </a:extLst>
-          </p:cNvPr>
+          <p:cNvPr id="2" name="Title 1"/>
           <p:cNvSpPr>
             <a:spLocks noGrp="1"/>
           </p:cNvSpPr>
@@ -1250,21 +1149,16 @@
           <a:lstStyle/>
           <a:p>
             <a:r>
-              <a:rPr lang="en-US"/>
+              <a:rPr lang="en-US" smtClean="0"/>
               <a:t>Click to edit Master title style</a:t>
             </a:r>
-          </a:p>
-        </p:txBody>
-      </p:sp>
-      <p:sp>
-        <p:nvSpPr>
-          <p:cNvPr id="3" name="Content Placeholder 2">
-            <a:extLst>
-              <a:ext uri="{FF2B5EF4-FFF2-40B4-BE49-F238E27FC236}">
-                <a16:creationId xmlns:a16="http://schemas.microsoft.com/office/drawing/2014/main" id="{16FDD166-DE5D-FECA-68D1-D8FF27BFC4BC}"/>
-              </a:ext>
-            </a:extLst>
-          </p:cNvPr>
+            <a:endParaRPr lang="en-US"/>
+          </a:p>
+        </p:txBody>
+      </p:sp>
+      <p:sp>
+        <p:nvSpPr>
+          <p:cNvPr id="3" name="Content Placeholder 2"/>
           <p:cNvSpPr>
             <a:spLocks noGrp="1"/>
           </p:cNvSpPr>
@@ -1274,59 +1168,82 @@
         </p:nvSpPr>
         <p:spPr>
           <a:xfrm>
-            <a:off x="838200" y="1825625"/>
-            <a:ext cx="5181600" cy="4351338"/>
+            <a:off x="457200" y="1600200"/>
+            <a:ext cx="4038600" cy="4525963"/>
           </a:xfrm>
         </p:spPr>
         <p:txBody>
           <a:bodyPr/>
-          <a:lstStyle/>
+          <a:lstStyle>
+            <a:lvl1pPr>
+              <a:defRPr sz="2800"/>
+            </a:lvl1pPr>
+            <a:lvl2pPr>
+              <a:defRPr sz="2400"/>
+            </a:lvl2pPr>
+            <a:lvl3pPr>
+              <a:defRPr sz="2000"/>
+            </a:lvl3pPr>
+            <a:lvl4pPr>
+              <a:defRPr sz="1800"/>
+            </a:lvl4pPr>
+            <a:lvl5pPr>
+              <a:defRPr sz="1800"/>
+            </a:lvl5pPr>
+            <a:lvl6pPr>
+              <a:defRPr sz="1800"/>
+            </a:lvl6pPr>
+            <a:lvl7pPr>
+              <a:defRPr sz="1800"/>
+            </a:lvl7pPr>
+            <a:lvl8pPr>
+              <a:defRPr sz="1800"/>
+            </a:lvl8pPr>
+            <a:lvl9pPr>
+              <a:defRPr sz="1800"/>
+            </a:lvl9pPr>
+          </a:lstStyle>
           <a:p>
             <a:pPr lvl="0"/>
             <a:r>
-              <a:rPr lang="en-US"/>
+              <a:rPr lang="en-US" smtClean="0"/>
               <a:t>Click to edit Master text styles</a:t>
             </a:r>
           </a:p>
           <a:p>
             <a:pPr lvl="1"/>
             <a:r>
-              <a:rPr lang="en-US"/>
+              <a:rPr lang="en-US" smtClean="0"/>
               <a:t>Second level</a:t>
             </a:r>
           </a:p>
           <a:p>
             <a:pPr lvl="2"/>
             <a:r>
-              <a:rPr lang="en-US"/>
+              <a:rPr lang="en-US" smtClean="0"/>
               <a:t>Third level</a:t>
             </a:r>
           </a:p>
           <a:p>
             <a:pPr lvl="3"/>
             <a:r>
-              <a:rPr lang="en-US"/>
+              <a:rPr lang="en-US" smtClean="0"/>
               <a:t>Fourth level</a:t>
             </a:r>
           </a:p>
           <a:p>
             <a:pPr lvl="4"/>
             <a:r>
-              <a:rPr lang="en-US"/>
+              <a:rPr lang="en-US" smtClean="0"/>
               <a:t>Fifth level</a:t>
             </a:r>
-          </a:p>
-        </p:txBody>
-      </p:sp>
-      <p:sp>
-        <p:nvSpPr>
-          <p:cNvPr id="4" name="Content Placeholder 3">
-            <a:extLst>
-              <a:ext uri="{FF2B5EF4-FFF2-40B4-BE49-F238E27FC236}">
-                <a16:creationId xmlns:a16="http://schemas.microsoft.com/office/drawing/2014/main" id="{BE15448C-2B77-D276-8951-C319DD0684C3}"/>
-              </a:ext>
-            </a:extLst>
-          </p:cNvPr>
+            <a:endParaRPr lang="en-US"/>
+          </a:p>
+        </p:txBody>
+      </p:sp>
+      <p:sp>
+        <p:nvSpPr>
+          <p:cNvPr id="4" name="Content Placeholder 3"/>
           <p:cNvSpPr>
             <a:spLocks noGrp="1"/>
           </p:cNvSpPr>
@@ -1336,59 +1253,82 @@
         </p:nvSpPr>
         <p:spPr>
           <a:xfrm>
-            <a:off x="6172200" y="1825625"/>
-            <a:ext cx="5181600" cy="4351338"/>
+            <a:off x="4648200" y="1600200"/>
+            <a:ext cx="4038600" cy="4525963"/>
           </a:xfrm>
         </p:spPr>
         <p:txBody>
           <a:bodyPr/>
-          <a:lstStyle/>
+          <a:lstStyle>
+            <a:lvl1pPr>
+              <a:defRPr sz="2800"/>
+            </a:lvl1pPr>
+            <a:lvl2pPr>
+              <a:defRPr sz="2400"/>
+            </a:lvl2pPr>
+            <a:lvl3pPr>
+              <a:defRPr sz="2000"/>
+            </a:lvl3pPr>
+            <a:lvl4pPr>
+              <a:defRPr sz="1800"/>
+            </a:lvl4pPr>
+            <a:lvl5pPr>
+              <a:defRPr sz="1800"/>
+            </a:lvl5pPr>
+            <a:lvl6pPr>
+              <a:defRPr sz="1800"/>
+            </a:lvl6pPr>
+            <a:lvl7pPr>
+              <a:defRPr sz="1800"/>
+            </a:lvl7pPr>
+            <a:lvl8pPr>
+              <a:defRPr sz="1800"/>
+            </a:lvl8pPr>
+            <a:lvl9pPr>
+              <a:defRPr sz="1800"/>
+            </a:lvl9pPr>
+          </a:lstStyle>
           <a:p>
             <a:pPr lvl="0"/>
             <a:r>
-              <a:rPr lang="en-US"/>
+              <a:rPr lang="en-US" smtClean="0"/>
               <a:t>Click to edit Master text styles</a:t>
             </a:r>
           </a:p>
           <a:p>
             <a:pPr lvl="1"/>
             <a:r>
-              <a:rPr lang="en-US"/>
+              <a:rPr lang="en-US" smtClean="0"/>
               <a:t>Second level</a:t>
             </a:r>
           </a:p>
           <a:p>
             <a:pPr lvl="2"/>
             <a:r>
-              <a:rPr lang="en-US"/>
+              <a:rPr lang="en-US" smtClean="0"/>
               <a:t>Third level</a:t>
             </a:r>
           </a:p>
           <a:p>
             <a:pPr lvl="3"/>
             <a:r>
-              <a:rPr lang="en-US"/>
+              <a:rPr lang="en-US" smtClean="0"/>
               <a:t>Fourth level</a:t>
             </a:r>
           </a:p>
           <a:p>
             <a:pPr lvl="4"/>
             <a:r>
-              <a:rPr lang="en-US"/>
+              <a:rPr lang="en-US" smtClean="0"/>
               <a:t>Fifth level</a:t>
             </a:r>
-          </a:p>
-        </p:txBody>
-      </p:sp>
-      <p:sp>
-        <p:nvSpPr>
-          <p:cNvPr id="5" name="Date Placeholder 4">
-            <a:extLst>
-              <a:ext uri="{FF2B5EF4-FFF2-40B4-BE49-F238E27FC236}">
-                <a16:creationId xmlns:a16="http://schemas.microsoft.com/office/drawing/2014/main" id="{F4A768DD-5C28-2588-C23C-CE7003F343E3}"/>
-              </a:ext>
-            </a:extLst>
-          </p:cNvPr>
+            <a:endParaRPr lang="en-US"/>
+          </a:p>
+        </p:txBody>
+      </p:sp>
+      <p:sp>
+        <p:nvSpPr>
+          <p:cNvPr id="5" name="Date Placeholder 4"/>
           <p:cNvSpPr>
             <a:spLocks noGrp="1"/>
           </p:cNvSpPr>
@@ -1401,9 +1341,9 @@
           <a:bodyPr/>
           <a:lstStyle/>
           <a:p>
-            <a:fld id="{77728346-2AB5-1B41-BB29-9C38D3698713}" type="datetimeFigureOut">
-              <a:rPr lang="en-US" smtClean="0"/>
-              <a:t>11/20/25</a:t>
+            <a:fld id="{5BCAD085-E8A6-8845-BD4E-CB4CCA059FC4}" type="datetimeFigureOut">
+              <a:rPr lang="en-US" smtClean="0"/>
+              <a:t>1/27/13</a:t>
             </a:fld>
             <a:endParaRPr lang="en-US"/>
           </a:p>
@@ -1411,13 +1351,7 @@
       </p:sp>
       <p:sp>
         <p:nvSpPr>
-          <p:cNvPr id="6" name="Footer Placeholder 5">
-            <a:extLst>
-              <a:ext uri="{FF2B5EF4-FFF2-40B4-BE49-F238E27FC236}">
-                <a16:creationId xmlns:a16="http://schemas.microsoft.com/office/drawing/2014/main" id="{C69E2A99-8BC0-D066-A065-B32BF089D7CC}"/>
-              </a:ext>
-            </a:extLst>
-          </p:cNvPr>
+          <p:cNvPr id="6" name="Footer Placeholder 5"/>
           <p:cNvSpPr>
             <a:spLocks noGrp="1"/>
           </p:cNvSpPr>
@@ -1436,13 +1370,7 @@
       </p:sp>
       <p:sp>
         <p:nvSpPr>
-          <p:cNvPr id="7" name="Slide Number Placeholder 6">
-            <a:extLst>
-              <a:ext uri="{FF2B5EF4-FFF2-40B4-BE49-F238E27FC236}">
-                <a16:creationId xmlns:a16="http://schemas.microsoft.com/office/drawing/2014/main" id="{6D4A4095-08FE-553F-39A4-28FF161DCC71}"/>
-              </a:ext>
-            </a:extLst>
-          </p:cNvPr>
+          <p:cNvPr id="7" name="Slide Number Placeholder 6"/>
           <p:cNvSpPr>
             <a:spLocks noGrp="1"/>
           </p:cNvSpPr>
@@ -1455,7 +1383,7 @@
           <a:bodyPr/>
           <a:lstStyle/>
           <a:p>
-            <a:fld id="{3DE4617C-001E-1047-A50C-4774964ACBA9}" type="slidenum">
+            <a:fld id="{C1FF6DA9-008F-8B48-92A6-B652298478BF}" type="slidenum">
               <a:rPr lang="en-US" smtClean="0"/>
               <a:t>‹#›</a:t>
             </a:fld>
@@ -1466,7 +1394,7 @@
     </p:spTree>
     <p:extLst>
       <p:ext uri="{BB962C8B-B14F-4D97-AF65-F5344CB8AC3E}">
-        <p14:creationId xmlns:p14="http://schemas.microsoft.com/office/powerpoint/2010/main" val="734083275"/>
+        <p14:creationId xmlns:p14="http://schemas.microsoft.com/office/powerpoint/2010/main" val="2782244947"/>
       </p:ext>
     </p:extLst>
   </p:cSld>
@@ -1495,57 +1423,45 @@
       </p:grpSpPr>
       <p:sp>
         <p:nvSpPr>
-          <p:cNvPr id="2" name="Title 1">
-            <a:extLst>
-              <a:ext uri="{FF2B5EF4-FFF2-40B4-BE49-F238E27FC236}">
-                <a16:creationId xmlns:a16="http://schemas.microsoft.com/office/drawing/2014/main" id="{EF300D68-CBC2-6C0A-51C0-3FD7D30FC9C5}"/>
-              </a:ext>
-            </a:extLst>
-          </p:cNvPr>
+          <p:cNvPr id="2" name="Title 1"/>
           <p:cNvSpPr>
             <a:spLocks noGrp="1"/>
           </p:cNvSpPr>
           <p:nvPr>
             <p:ph type="title"/>
+          </p:nvPr>
+        </p:nvSpPr>
+        <p:spPr/>
+        <p:txBody>
+          <a:bodyPr/>
+          <a:lstStyle>
+            <a:lvl1pPr>
+              <a:defRPr/>
+            </a:lvl1pPr>
+          </a:lstStyle>
+          <a:p>
+            <a:r>
+              <a:rPr lang="en-US" smtClean="0"/>
+              <a:t>Click to edit Master title style</a:t>
+            </a:r>
+            <a:endParaRPr lang="en-US"/>
+          </a:p>
+        </p:txBody>
+      </p:sp>
+      <p:sp>
+        <p:nvSpPr>
+          <p:cNvPr id="3" name="Text Placeholder 2"/>
+          <p:cNvSpPr>
+            <a:spLocks noGrp="1"/>
+          </p:cNvSpPr>
+          <p:nvPr>
+            <p:ph type="body" idx="1"/>
           </p:nvPr>
         </p:nvSpPr>
         <p:spPr>
           <a:xfrm>
-            <a:off x="839788" y="365125"/>
-            <a:ext cx="10515600" cy="1325563"/>
-          </a:xfrm>
-        </p:spPr>
-        <p:txBody>
-          <a:bodyPr/>
-          <a:lstStyle/>
-          <a:p>
-            <a:r>
-              <a:rPr lang="en-US"/>
-              <a:t>Click to edit Master title style</a:t>
-            </a:r>
-          </a:p>
-        </p:txBody>
-      </p:sp>
-      <p:sp>
-        <p:nvSpPr>
-          <p:cNvPr id="3" name="Text Placeholder 2">
-            <a:extLst>
-              <a:ext uri="{FF2B5EF4-FFF2-40B4-BE49-F238E27FC236}">
-                <a16:creationId xmlns:a16="http://schemas.microsoft.com/office/drawing/2014/main" id="{0156A0E0-32AE-54A3-16AB-1D01CFCA9063}"/>
-              </a:ext>
-            </a:extLst>
-          </p:cNvPr>
-          <p:cNvSpPr>
-            <a:spLocks noGrp="1"/>
-          </p:cNvSpPr>
-          <p:nvPr>
-            <p:ph type="body" idx="1"/>
-          </p:nvPr>
-        </p:nvSpPr>
-        <p:spPr>
-          <a:xfrm>
-            <a:off x="839788" y="1681163"/>
-            <a:ext cx="5157787" cy="823912"/>
+            <a:off x="457200" y="1535113"/>
+            <a:ext cx="4040188" cy="639762"/>
           </a:xfrm>
         </p:spPr>
         <p:txBody>
@@ -1591,7 +1507,7 @@
           <a:p>
             <a:pPr lvl="0"/>
             <a:r>
-              <a:rPr lang="en-US"/>
+              <a:rPr lang="en-US" smtClean="0"/>
               <a:t>Click to edit Master text styles</a:t>
             </a:r>
           </a:p>
@@ -1599,13 +1515,7 @@
       </p:sp>
       <p:sp>
         <p:nvSpPr>
-          <p:cNvPr id="4" name="Content Placeholder 3">
-            <a:extLst>
-              <a:ext uri="{FF2B5EF4-FFF2-40B4-BE49-F238E27FC236}">
-                <a16:creationId xmlns:a16="http://schemas.microsoft.com/office/drawing/2014/main" id="{8E6E2160-C836-AB81-C2A7-B2B030705296}"/>
-              </a:ext>
-            </a:extLst>
-          </p:cNvPr>
+          <p:cNvPr id="4" name="Content Placeholder 3"/>
           <p:cNvSpPr>
             <a:spLocks noGrp="1"/>
           </p:cNvSpPr>
@@ -1615,59 +1525,82 @@
         </p:nvSpPr>
         <p:spPr>
           <a:xfrm>
-            <a:off x="839788" y="2505075"/>
-            <a:ext cx="5157787" cy="3684588"/>
+            <a:off x="457200" y="2174875"/>
+            <a:ext cx="4040188" cy="3951288"/>
           </a:xfrm>
         </p:spPr>
         <p:txBody>
           <a:bodyPr/>
-          <a:lstStyle/>
+          <a:lstStyle>
+            <a:lvl1pPr>
+              <a:defRPr sz="2400"/>
+            </a:lvl1pPr>
+            <a:lvl2pPr>
+              <a:defRPr sz="2000"/>
+            </a:lvl2pPr>
+            <a:lvl3pPr>
+              <a:defRPr sz="1800"/>
+            </a:lvl3pPr>
+            <a:lvl4pPr>
+              <a:defRPr sz="1600"/>
+            </a:lvl4pPr>
+            <a:lvl5pPr>
+              <a:defRPr sz="1600"/>
+            </a:lvl5pPr>
+            <a:lvl6pPr>
+              <a:defRPr sz="1600"/>
+            </a:lvl6pPr>
+            <a:lvl7pPr>
+              <a:defRPr sz="1600"/>
+            </a:lvl7pPr>
+            <a:lvl8pPr>
+              <a:defRPr sz="1600"/>
+            </a:lvl8pPr>
+            <a:lvl9pPr>
+              <a:defRPr sz="1600"/>
+            </a:lvl9pPr>
+          </a:lstStyle>
           <a:p>
             <a:pPr lvl="0"/>
             <a:r>
-              <a:rPr lang="en-US"/>
+              <a:rPr lang="en-US" smtClean="0"/>
               <a:t>Click to edit Master text styles</a:t>
             </a:r>
           </a:p>
           <a:p>
             <a:pPr lvl="1"/>
             <a:r>
-              <a:rPr lang="en-US"/>
+              <a:rPr lang="en-US" smtClean="0"/>
               <a:t>Second level</a:t>
             </a:r>
           </a:p>
           <a:p>
             <a:pPr lvl="2"/>
             <a:r>
-              <a:rPr lang="en-US"/>
+              <a:rPr lang="en-US" smtClean="0"/>
               <a:t>Third level</a:t>
             </a:r>
           </a:p>
           <a:p>
             <a:pPr lvl="3"/>
             <a:r>
-              <a:rPr lang="en-US"/>
+              <a:rPr lang="en-US" smtClean="0"/>
               <a:t>Fourth level</a:t>
             </a:r>
           </a:p>
           <a:p>
             <a:pPr lvl="4"/>
             <a:r>
-              <a:rPr lang="en-US"/>
+              <a:rPr lang="en-US" smtClean="0"/>
               <a:t>Fifth level</a:t>
             </a:r>
-          </a:p>
-        </p:txBody>
-      </p:sp>
-      <p:sp>
-        <p:nvSpPr>
-          <p:cNvPr id="5" name="Text Placeholder 4">
-            <a:extLst>
-              <a:ext uri="{FF2B5EF4-FFF2-40B4-BE49-F238E27FC236}">
-                <a16:creationId xmlns:a16="http://schemas.microsoft.com/office/drawing/2014/main" id="{9F673966-15A8-5F89-E17B-FF65260BBE69}"/>
-              </a:ext>
-            </a:extLst>
-          </p:cNvPr>
+            <a:endParaRPr lang="en-US"/>
+          </a:p>
+        </p:txBody>
+      </p:sp>
+      <p:sp>
+        <p:nvSpPr>
+          <p:cNvPr id="5" name="Text Placeholder 4"/>
           <p:cNvSpPr>
             <a:spLocks noGrp="1"/>
           </p:cNvSpPr>
@@ -1677,8 +1610,8 @@
         </p:nvSpPr>
         <p:spPr>
           <a:xfrm>
-            <a:off x="6172200" y="1681163"/>
-            <a:ext cx="5183188" cy="823912"/>
+            <a:off x="4645025" y="1535113"/>
+            <a:ext cx="4041775" cy="639762"/>
           </a:xfrm>
         </p:spPr>
         <p:txBody>
@@ -1724,7 +1657,7 @@
           <a:p>
             <a:pPr lvl="0"/>
             <a:r>
-              <a:rPr lang="en-US"/>
+              <a:rPr lang="en-US" smtClean="0"/>
               <a:t>Click to edit Master text styles</a:t>
             </a:r>
           </a:p>
@@ -1732,13 +1665,7 @@
       </p:sp>
       <p:sp>
         <p:nvSpPr>
-          <p:cNvPr id="6" name="Content Placeholder 5">
-            <a:extLst>
-              <a:ext uri="{FF2B5EF4-FFF2-40B4-BE49-F238E27FC236}">
-                <a16:creationId xmlns:a16="http://schemas.microsoft.com/office/drawing/2014/main" id="{6EC350CB-B4C0-F071-C00D-4D14A4D39E16}"/>
-              </a:ext>
-            </a:extLst>
-          </p:cNvPr>
+          <p:cNvPr id="6" name="Content Placeholder 5"/>
           <p:cNvSpPr>
             <a:spLocks noGrp="1"/>
           </p:cNvSpPr>
@@ -1748,59 +1675,82 @@
         </p:nvSpPr>
         <p:spPr>
           <a:xfrm>
-            <a:off x="6172200" y="2505075"/>
-            <a:ext cx="5183188" cy="3684588"/>
+            <a:off x="4645025" y="2174875"/>
+            <a:ext cx="4041775" cy="3951288"/>
           </a:xfrm>
         </p:spPr>
         <p:txBody>
           <a:bodyPr/>
-          <a:lstStyle/>
+          <a:lstStyle>
+            <a:lvl1pPr>
+              <a:defRPr sz="2400"/>
+            </a:lvl1pPr>
+            <a:lvl2pPr>
+              <a:defRPr sz="2000"/>
+            </a:lvl2pPr>
+            <a:lvl3pPr>
+              <a:defRPr sz="1800"/>
+            </a:lvl3pPr>
+            <a:lvl4pPr>
+              <a:defRPr sz="1600"/>
+            </a:lvl4pPr>
+            <a:lvl5pPr>
+              <a:defRPr sz="1600"/>
+            </a:lvl5pPr>
+            <a:lvl6pPr>
+              <a:defRPr sz="1600"/>
+            </a:lvl6pPr>
+            <a:lvl7pPr>
+              <a:defRPr sz="1600"/>
+            </a:lvl7pPr>
+            <a:lvl8pPr>
+              <a:defRPr sz="1600"/>
+            </a:lvl8pPr>
+            <a:lvl9pPr>
+              <a:defRPr sz="1600"/>
+            </a:lvl9pPr>
+          </a:lstStyle>
           <a:p>
             <a:pPr lvl="0"/>
             <a:r>
-              <a:rPr lang="en-US"/>
+              <a:rPr lang="en-US" smtClean="0"/>
               <a:t>Click to edit Master text styles</a:t>
             </a:r>
           </a:p>
           <a:p>
             <a:pPr lvl="1"/>
             <a:r>
-              <a:rPr lang="en-US"/>
+              <a:rPr lang="en-US" smtClean="0"/>
               <a:t>Second level</a:t>
             </a:r>
           </a:p>
           <a:p>
             <a:pPr lvl="2"/>
             <a:r>
-              <a:rPr lang="en-US"/>
+              <a:rPr lang="en-US" smtClean="0"/>
               <a:t>Third level</a:t>
             </a:r>
           </a:p>
           <a:p>
             <a:pPr lvl="3"/>
             <a:r>
-              <a:rPr lang="en-US"/>
+              <a:rPr lang="en-US" smtClean="0"/>
               <a:t>Fourth level</a:t>
             </a:r>
           </a:p>
           <a:p>
             <a:pPr lvl="4"/>
             <a:r>
-              <a:rPr lang="en-US"/>
+              <a:rPr lang="en-US" smtClean="0"/>
               <a:t>Fifth level</a:t>
             </a:r>
-          </a:p>
-        </p:txBody>
-      </p:sp>
-      <p:sp>
-        <p:nvSpPr>
-          <p:cNvPr id="7" name="Date Placeholder 6">
-            <a:extLst>
-              <a:ext uri="{FF2B5EF4-FFF2-40B4-BE49-F238E27FC236}">
-                <a16:creationId xmlns:a16="http://schemas.microsoft.com/office/drawing/2014/main" id="{3AE0BF05-DBB1-81B1-67E7-945D887FAEBA}"/>
-              </a:ext>
-            </a:extLst>
-          </p:cNvPr>
+            <a:endParaRPr lang="en-US"/>
+          </a:p>
+        </p:txBody>
+      </p:sp>
+      <p:sp>
+        <p:nvSpPr>
+          <p:cNvPr id="7" name="Date Placeholder 6"/>
           <p:cNvSpPr>
             <a:spLocks noGrp="1"/>
           </p:cNvSpPr>
@@ -1813,9 +1763,9 @@
           <a:bodyPr/>
           <a:lstStyle/>
           <a:p>
-            <a:fld id="{77728346-2AB5-1B41-BB29-9C38D3698713}" type="datetimeFigureOut">
-              <a:rPr lang="en-US" smtClean="0"/>
-              <a:t>11/20/25</a:t>
+            <a:fld id="{5BCAD085-E8A6-8845-BD4E-CB4CCA059FC4}" type="datetimeFigureOut">
+              <a:rPr lang="en-US" smtClean="0"/>
+              <a:t>1/27/13</a:t>
             </a:fld>
             <a:endParaRPr lang="en-US"/>
           </a:p>
@@ -1823,13 +1773,7 @@
       </p:sp>
       <p:sp>
         <p:nvSpPr>
-          <p:cNvPr id="8" name="Footer Placeholder 7">
-            <a:extLst>
-              <a:ext uri="{FF2B5EF4-FFF2-40B4-BE49-F238E27FC236}">
-                <a16:creationId xmlns:a16="http://schemas.microsoft.com/office/drawing/2014/main" id="{7ED8A4E2-CB9E-0F6A-1D4F-FB989054F044}"/>
-              </a:ext>
-            </a:extLst>
-          </p:cNvPr>
+          <p:cNvPr id="8" name="Footer Placeholder 7"/>
           <p:cNvSpPr>
             <a:spLocks noGrp="1"/>
           </p:cNvSpPr>
@@ -1848,13 +1792,7 @@
       </p:sp>
       <p:sp>
         <p:nvSpPr>
-          <p:cNvPr id="9" name="Slide Number Placeholder 8">
-            <a:extLst>
-              <a:ext uri="{FF2B5EF4-FFF2-40B4-BE49-F238E27FC236}">
-                <a16:creationId xmlns:a16="http://schemas.microsoft.com/office/drawing/2014/main" id="{EF244C34-D558-1E5C-9B0E-CCE21A97BC90}"/>
-              </a:ext>
-            </a:extLst>
-          </p:cNvPr>
+          <p:cNvPr id="9" name="Slide Number Placeholder 8"/>
           <p:cNvSpPr>
             <a:spLocks noGrp="1"/>
           </p:cNvSpPr>
@@ -1867,7 +1805,7 @@
           <a:bodyPr/>
           <a:lstStyle/>
           <a:p>
-            <a:fld id="{3DE4617C-001E-1047-A50C-4774964ACBA9}" type="slidenum">
+            <a:fld id="{C1FF6DA9-008F-8B48-92A6-B652298478BF}" type="slidenum">
               <a:rPr lang="en-US" smtClean="0"/>
               <a:t>‹#›</a:t>
             </a:fld>
@@ -1878,7 +1816,7 @@
     </p:spTree>
     <p:extLst>
       <p:ext uri="{BB962C8B-B14F-4D97-AF65-F5344CB8AC3E}">
-        <p14:creationId xmlns:p14="http://schemas.microsoft.com/office/powerpoint/2010/main" val="3476791690"/>
+        <p14:creationId xmlns:p14="http://schemas.microsoft.com/office/powerpoint/2010/main" val="990158736"/>
       </p:ext>
     </p:extLst>
   </p:cSld>
@@ -1907,13 +1845,7 @@
       </p:grpSpPr>
       <p:sp>
         <p:nvSpPr>
-          <p:cNvPr id="2" name="Title 1">
-            <a:extLst>
-              <a:ext uri="{FF2B5EF4-FFF2-40B4-BE49-F238E27FC236}">
-                <a16:creationId xmlns:a16="http://schemas.microsoft.com/office/drawing/2014/main" id="{F0881F88-8249-1A0E-207D-3F81FD20B627}"/>
-              </a:ext>
-            </a:extLst>
-          </p:cNvPr>
+          <p:cNvPr id="2" name="Title 1"/>
           <p:cNvSpPr>
             <a:spLocks noGrp="1"/>
           </p:cNvSpPr>
@@ -1927,21 +1859,16 @@
           <a:lstStyle/>
           <a:p>
             <a:r>
-              <a:rPr lang="en-US"/>
+              <a:rPr lang="en-US" smtClean="0"/>
               <a:t>Click to edit Master title style</a:t>
             </a:r>
-          </a:p>
-        </p:txBody>
-      </p:sp>
-      <p:sp>
-        <p:nvSpPr>
-          <p:cNvPr id="3" name="Date Placeholder 2">
-            <a:extLst>
-              <a:ext uri="{FF2B5EF4-FFF2-40B4-BE49-F238E27FC236}">
-                <a16:creationId xmlns:a16="http://schemas.microsoft.com/office/drawing/2014/main" id="{C6A9AC5E-9057-B249-42C2-6359B084CAC4}"/>
-              </a:ext>
-            </a:extLst>
-          </p:cNvPr>
+            <a:endParaRPr lang="en-US"/>
+          </a:p>
+        </p:txBody>
+      </p:sp>
+      <p:sp>
+        <p:nvSpPr>
+          <p:cNvPr id="3" name="Date Placeholder 2"/>
           <p:cNvSpPr>
             <a:spLocks noGrp="1"/>
           </p:cNvSpPr>
@@ -1954,9 +1881,9 @@
           <a:bodyPr/>
           <a:lstStyle/>
           <a:p>
-            <a:fld id="{77728346-2AB5-1B41-BB29-9C38D3698713}" type="datetimeFigureOut">
-              <a:rPr lang="en-US" smtClean="0"/>
-              <a:t>11/20/25</a:t>
+            <a:fld id="{5BCAD085-E8A6-8845-BD4E-CB4CCA059FC4}" type="datetimeFigureOut">
+              <a:rPr lang="en-US" smtClean="0"/>
+              <a:t>1/27/13</a:t>
             </a:fld>
             <a:endParaRPr lang="en-US"/>
           </a:p>
@@ -1964,13 +1891,7 @@
       </p:sp>
       <p:sp>
         <p:nvSpPr>
-          <p:cNvPr id="4" name="Footer Placeholder 3">
-            <a:extLst>
-              <a:ext uri="{FF2B5EF4-FFF2-40B4-BE49-F238E27FC236}">
-                <a16:creationId xmlns:a16="http://schemas.microsoft.com/office/drawing/2014/main" id="{55281CCC-D047-7A02-9A2C-EBA731F541FB}"/>
-              </a:ext>
-            </a:extLst>
-          </p:cNvPr>
+          <p:cNvPr id="4" name="Footer Placeholder 3"/>
           <p:cNvSpPr>
             <a:spLocks noGrp="1"/>
           </p:cNvSpPr>
@@ -1989,13 +1910,7 @@
       </p:sp>
       <p:sp>
         <p:nvSpPr>
-          <p:cNvPr id="5" name="Slide Number Placeholder 4">
-            <a:extLst>
-              <a:ext uri="{FF2B5EF4-FFF2-40B4-BE49-F238E27FC236}">
-                <a16:creationId xmlns:a16="http://schemas.microsoft.com/office/drawing/2014/main" id="{5D04D47C-029F-436B-ABA9-B338A8744D17}"/>
-              </a:ext>
-            </a:extLst>
-          </p:cNvPr>
+          <p:cNvPr id="5" name="Slide Number Placeholder 4"/>
           <p:cNvSpPr>
             <a:spLocks noGrp="1"/>
           </p:cNvSpPr>
@@ -2008,7 +1923,7 @@
           <a:bodyPr/>
           <a:lstStyle/>
           <a:p>
-            <a:fld id="{3DE4617C-001E-1047-A50C-4774964ACBA9}" type="slidenum">
+            <a:fld id="{C1FF6DA9-008F-8B48-92A6-B652298478BF}" type="slidenum">
               <a:rPr lang="en-US" smtClean="0"/>
               <a:t>‹#›</a:t>
             </a:fld>
@@ -2019,7 +1934,7 @@
     </p:spTree>
     <p:extLst>
       <p:ext uri="{BB962C8B-B14F-4D97-AF65-F5344CB8AC3E}">
-        <p14:creationId xmlns:p14="http://schemas.microsoft.com/office/powerpoint/2010/main" val="2942702028"/>
+        <p14:creationId xmlns:p14="http://schemas.microsoft.com/office/powerpoint/2010/main" val="727027711"/>
       </p:ext>
     </p:extLst>
   </p:cSld>
@@ -2048,13 +1963,7 @@
       </p:grpSpPr>
       <p:sp>
         <p:nvSpPr>
-          <p:cNvPr id="2" name="Date Placeholder 1">
-            <a:extLst>
-              <a:ext uri="{FF2B5EF4-FFF2-40B4-BE49-F238E27FC236}">
-                <a16:creationId xmlns:a16="http://schemas.microsoft.com/office/drawing/2014/main" id="{F0686F2A-F2B8-93CE-B2CC-FF3040C6F5CE}"/>
-              </a:ext>
-            </a:extLst>
-          </p:cNvPr>
+          <p:cNvPr id="2" name="Date Placeholder 1"/>
           <p:cNvSpPr>
             <a:spLocks noGrp="1"/>
           </p:cNvSpPr>
@@ -2067,9 +1976,9 @@
           <a:bodyPr/>
           <a:lstStyle/>
           <a:p>
-            <a:fld id="{77728346-2AB5-1B41-BB29-9C38D3698713}" type="datetimeFigureOut">
-              <a:rPr lang="en-US" smtClean="0"/>
-              <a:t>11/20/25</a:t>
+            <a:fld id="{5BCAD085-E8A6-8845-BD4E-CB4CCA059FC4}" type="datetimeFigureOut">
+              <a:rPr lang="en-US" smtClean="0"/>
+              <a:t>1/27/13</a:t>
             </a:fld>
             <a:endParaRPr lang="en-US"/>
           </a:p>
@@ -2077,13 +1986,7 @@
       </p:sp>
       <p:sp>
         <p:nvSpPr>
-          <p:cNvPr id="3" name="Footer Placeholder 2">
-            <a:extLst>
-              <a:ext uri="{FF2B5EF4-FFF2-40B4-BE49-F238E27FC236}">
-                <a16:creationId xmlns:a16="http://schemas.microsoft.com/office/drawing/2014/main" id="{D044BE2D-39D3-9C73-B22A-F8F7270AC039}"/>
-              </a:ext>
-            </a:extLst>
-          </p:cNvPr>
+          <p:cNvPr id="3" name="Footer Placeholder 2"/>
           <p:cNvSpPr>
             <a:spLocks noGrp="1"/>
           </p:cNvSpPr>
@@ -2102,13 +2005,7 @@
       </p:sp>
       <p:sp>
         <p:nvSpPr>
-          <p:cNvPr id="4" name="Slide Number Placeholder 3">
-            <a:extLst>
-              <a:ext uri="{FF2B5EF4-FFF2-40B4-BE49-F238E27FC236}">
-                <a16:creationId xmlns:a16="http://schemas.microsoft.com/office/drawing/2014/main" id="{A0EB66FE-E905-21F6-4F62-6ACCE39DE663}"/>
-              </a:ext>
-            </a:extLst>
-          </p:cNvPr>
+          <p:cNvPr id="4" name="Slide Number Placeholder 3"/>
           <p:cNvSpPr>
             <a:spLocks noGrp="1"/>
           </p:cNvSpPr>
@@ -2121,7 +2018,7 @@
           <a:bodyPr/>
           <a:lstStyle/>
           <a:p>
-            <a:fld id="{3DE4617C-001E-1047-A50C-4774964ACBA9}" type="slidenum">
+            <a:fld id="{C1FF6DA9-008F-8B48-92A6-B652298478BF}" type="slidenum">
               <a:rPr lang="en-US" smtClean="0"/>
               <a:t>‹#›</a:t>
             </a:fld>
@@ -2132,7 +2029,7 @@
     </p:spTree>
     <p:extLst>
       <p:ext uri="{BB962C8B-B14F-4D97-AF65-F5344CB8AC3E}">
-        <p14:creationId xmlns:p14="http://schemas.microsoft.com/office/powerpoint/2010/main" val="1870564864"/>
+        <p14:creationId xmlns:p14="http://schemas.microsoft.com/office/powerpoint/2010/main" val="1212999818"/>
       </p:ext>
     </p:extLst>
   </p:cSld>
@@ -2161,13 +2058,7 @@
       </p:grpSpPr>
       <p:sp>
         <p:nvSpPr>
-          <p:cNvPr id="2" name="Title 1">
-            <a:extLst>
-              <a:ext uri="{FF2B5EF4-FFF2-40B4-BE49-F238E27FC236}">
-                <a16:creationId xmlns:a16="http://schemas.microsoft.com/office/drawing/2014/main" id="{84E3852C-C165-E54F-E987-637C4561B199}"/>
-              </a:ext>
-            </a:extLst>
-          </p:cNvPr>
+          <p:cNvPr id="2" name="Title 1"/>
           <p:cNvSpPr>
             <a:spLocks noGrp="1"/>
           </p:cNvSpPr>
@@ -2177,34 +2068,29 @@
         </p:nvSpPr>
         <p:spPr>
           <a:xfrm>
-            <a:off x="839788" y="457200"/>
-            <a:ext cx="3932237" cy="1600200"/>
+            <a:off x="457200" y="273050"/>
+            <a:ext cx="3008313" cy="1162050"/>
           </a:xfrm>
         </p:spPr>
         <p:txBody>
           <a:bodyPr anchor="b"/>
           <a:lstStyle>
-            <a:lvl1pPr>
-              <a:defRPr sz="3200"/>
+            <a:lvl1pPr algn="l">
+              <a:defRPr sz="2000" b="1"/>
             </a:lvl1pPr>
           </a:lstStyle>
           <a:p>
             <a:r>
-              <a:rPr lang="en-US"/>
+              <a:rPr lang="en-US" smtClean="0"/>
               <a:t>Click to edit Master title style</a:t>
             </a:r>
-          </a:p>
-        </p:txBody>
-      </p:sp>
-      <p:sp>
-        <p:nvSpPr>
-          <p:cNvPr id="3" name="Content Placeholder 2">
-            <a:extLst>
-              <a:ext uri="{FF2B5EF4-FFF2-40B4-BE49-F238E27FC236}">
-                <a16:creationId xmlns:a16="http://schemas.microsoft.com/office/drawing/2014/main" id="{2C538232-355A-B42C-B740-B6A44EA7E5A3}"/>
-              </a:ext>
-            </a:extLst>
-          </p:cNvPr>
+            <a:endParaRPr lang="en-US"/>
+          </a:p>
+        </p:txBody>
+      </p:sp>
+      <p:sp>
+        <p:nvSpPr>
+          <p:cNvPr id="3" name="Content Placeholder 2"/>
           <p:cNvSpPr>
             <a:spLocks noGrp="1"/>
           </p:cNvSpPr>
@@ -2214,8 +2100,8 @@
         </p:nvSpPr>
         <p:spPr>
           <a:xfrm>
-            <a:off x="5183188" y="987425"/>
-            <a:ext cx="6172200" cy="4873625"/>
+            <a:off x="3575050" y="273050"/>
+            <a:ext cx="5111750" cy="5853113"/>
           </a:xfrm>
         </p:spPr>
         <p:txBody>
@@ -2252,49 +2138,44 @@
           <a:p>
             <a:pPr lvl="0"/>
             <a:r>
-              <a:rPr lang="en-US"/>
+              <a:rPr lang="en-US" smtClean="0"/>
               <a:t>Click to edit Master text styles</a:t>
             </a:r>
           </a:p>
           <a:p>
             <a:pPr lvl="1"/>
             <a:r>
-              <a:rPr lang="en-US"/>
+              <a:rPr lang="en-US" smtClean="0"/>
               <a:t>Second level</a:t>
             </a:r>
           </a:p>
           <a:p>
             <a:pPr lvl="2"/>
             <a:r>
-              <a:rPr lang="en-US"/>
+              <a:rPr lang="en-US" smtClean="0"/>
               <a:t>Third level</a:t>
             </a:r>
           </a:p>
           <a:p>
             <a:pPr lvl="3"/>
             <a:r>
-              <a:rPr lang="en-US"/>
+              <a:rPr lang="en-US" smtClean="0"/>
               <a:t>Fourth level</a:t>
             </a:r>
           </a:p>
           <a:p>
             <a:pPr lvl="4"/>
             <a:r>
-              <a:rPr lang="en-US"/>
+              <a:rPr lang="en-US" smtClean="0"/>
               <a:t>Fifth level</a:t>
             </a:r>
-          </a:p>
-        </p:txBody>
-      </p:sp>
-      <p:sp>
-        <p:nvSpPr>
-          <p:cNvPr id="4" name="Text Placeholder 3">
-            <a:extLst>
-              <a:ext uri="{FF2B5EF4-FFF2-40B4-BE49-F238E27FC236}">
-                <a16:creationId xmlns:a16="http://schemas.microsoft.com/office/drawing/2014/main" id="{37FED526-A226-EB4D-C4F2-EACC9980D1C2}"/>
-              </a:ext>
-            </a:extLst>
-          </p:cNvPr>
+            <a:endParaRPr lang="en-US"/>
+          </a:p>
+        </p:txBody>
+      </p:sp>
+      <p:sp>
+        <p:nvSpPr>
+          <p:cNvPr id="4" name="Text Placeholder 3"/>
           <p:cNvSpPr>
             <a:spLocks noGrp="1"/>
           </p:cNvSpPr>
@@ -2304,8 +2185,8 @@
         </p:nvSpPr>
         <p:spPr>
           <a:xfrm>
-            <a:off x="839788" y="2057400"/>
-            <a:ext cx="3932237" cy="3811588"/>
+            <a:off x="457200" y="1435100"/>
+            <a:ext cx="3008313" cy="4691063"/>
           </a:xfrm>
         </p:spPr>
         <p:txBody>
@@ -2313,45 +2194,45 @@
           <a:lstStyle>
             <a:lvl1pPr marL="0" indent="0">
               <a:buNone/>
-              <a:defRPr sz="1600"/>
+              <a:defRPr sz="1400"/>
             </a:lvl1pPr>
             <a:lvl2pPr marL="457200" indent="0">
               <a:buNone/>
-              <a:defRPr sz="1400"/>
+              <a:defRPr sz="1200"/>
             </a:lvl2pPr>
             <a:lvl3pPr marL="914400" indent="0">
               <a:buNone/>
-              <a:defRPr sz="1200"/>
+              <a:defRPr sz="1000"/>
             </a:lvl3pPr>
             <a:lvl4pPr marL="1371600" indent="0">
               <a:buNone/>
-              <a:defRPr sz="1000"/>
+              <a:defRPr sz="900"/>
             </a:lvl4pPr>
             <a:lvl5pPr marL="1828800" indent="0">
               <a:buNone/>
-              <a:defRPr sz="1000"/>
+              <a:defRPr sz="900"/>
             </a:lvl5pPr>
             <a:lvl6pPr marL="2286000" indent="0">
               <a:buNone/>
-              <a:defRPr sz="1000"/>
+              <a:defRPr sz="900"/>
             </a:lvl6pPr>
             <a:lvl7pPr marL="2743200" indent="0">
               <a:buNone/>
-              <a:defRPr sz="1000"/>
+              <a:defRPr sz="900"/>
             </a:lvl7pPr>
             <a:lvl8pPr marL="3200400" indent="0">
               <a:buNone/>
-              <a:defRPr sz="1000"/>
+              <a:defRPr sz="900"/>
             </a:lvl8pPr>
             <a:lvl9pPr marL="3657600" indent="0">
               <a:buNone/>
-              <a:defRPr sz="1000"/>
+              <a:defRPr sz="900"/>
             </a:lvl9pPr>
           </a:lstStyle>
           <a:p>
             <a:pPr lvl="0"/>
             <a:r>
-              <a:rPr lang="en-US"/>
+              <a:rPr lang="en-US" smtClean="0"/>
               <a:t>Click to edit Master text styles</a:t>
             </a:r>
           </a:p>
@@ -2359,13 +2240,7 @@
       </p:sp>
       <p:sp>
         <p:nvSpPr>
-          <p:cNvPr id="5" name="Date Placeholder 4">
-            <a:extLst>
-              <a:ext uri="{FF2B5EF4-FFF2-40B4-BE49-F238E27FC236}">
-                <a16:creationId xmlns:a16="http://schemas.microsoft.com/office/drawing/2014/main" id="{7A89F0AD-2016-658D-3468-3A9715BCD3AA}"/>
-              </a:ext>
-            </a:extLst>
-          </p:cNvPr>
+          <p:cNvPr id="5" name="Date Placeholder 4"/>
           <p:cNvSpPr>
             <a:spLocks noGrp="1"/>
           </p:cNvSpPr>
@@ -2378,9 +2253,9 @@
           <a:bodyPr/>
           <a:lstStyle/>
           <a:p>
-            <a:fld id="{77728346-2AB5-1B41-BB29-9C38D3698713}" type="datetimeFigureOut">
-              <a:rPr lang="en-US" smtClean="0"/>
-              <a:t>11/20/25</a:t>
+            <a:fld id="{5BCAD085-E8A6-8845-BD4E-CB4CCA059FC4}" type="datetimeFigureOut">
+              <a:rPr lang="en-US" smtClean="0"/>
+              <a:t>1/27/13</a:t>
             </a:fld>
             <a:endParaRPr lang="en-US"/>
           </a:p>
@@ -2388,13 +2263,7 @@
       </p:sp>
       <p:sp>
         <p:nvSpPr>
-          <p:cNvPr id="6" name="Footer Placeholder 5">
-            <a:extLst>
-              <a:ext uri="{FF2B5EF4-FFF2-40B4-BE49-F238E27FC236}">
-                <a16:creationId xmlns:a16="http://schemas.microsoft.com/office/drawing/2014/main" id="{9F793379-B0A6-8047-872F-D800A090144F}"/>
-              </a:ext>
-            </a:extLst>
-          </p:cNvPr>
+          <p:cNvPr id="6" name="Footer Placeholder 5"/>
           <p:cNvSpPr>
             <a:spLocks noGrp="1"/>
           </p:cNvSpPr>
@@ -2413,13 +2282,7 @@
       </p:sp>
       <p:sp>
         <p:nvSpPr>
-          <p:cNvPr id="7" name="Slide Number Placeholder 6">
-            <a:extLst>
-              <a:ext uri="{FF2B5EF4-FFF2-40B4-BE49-F238E27FC236}">
-                <a16:creationId xmlns:a16="http://schemas.microsoft.com/office/drawing/2014/main" id="{34BD3F3A-E5BF-9930-51F5-675D14CFD57E}"/>
-              </a:ext>
-            </a:extLst>
-          </p:cNvPr>
+          <p:cNvPr id="7" name="Slide Number Placeholder 6"/>
           <p:cNvSpPr>
             <a:spLocks noGrp="1"/>
           </p:cNvSpPr>
@@ -2432,7 +2295,7 @@
           <a:bodyPr/>
           <a:lstStyle/>
           <a:p>
-            <a:fld id="{3DE4617C-001E-1047-A50C-4774964ACBA9}" type="slidenum">
+            <a:fld id="{C1FF6DA9-008F-8B48-92A6-B652298478BF}" type="slidenum">
               <a:rPr lang="en-US" smtClean="0"/>
               <a:t>‹#›</a:t>
             </a:fld>
@@ -2443,7 +2306,7 @@
     </p:spTree>
     <p:extLst>
       <p:ext uri="{BB962C8B-B14F-4D97-AF65-F5344CB8AC3E}">
-        <p14:creationId xmlns:p14="http://schemas.microsoft.com/office/powerpoint/2010/main" val="1305376054"/>
+        <p14:creationId xmlns:p14="http://schemas.microsoft.com/office/powerpoint/2010/main" val="1840726560"/>
       </p:ext>
     </p:extLst>
   </p:cSld>
@@ -2472,13 +2335,7 @@
       </p:grpSpPr>
       <p:sp>
         <p:nvSpPr>
-          <p:cNvPr id="2" name="Title 1">
-            <a:extLst>
-              <a:ext uri="{FF2B5EF4-FFF2-40B4-BE49-F238E27FC236}">
-                <a16:creationId xmlns:a16="http://schemas.microsoft.com/office/drawing/2014/main" id="{B3E1FD10-1485-9F16-8F4D-AC4BB8AEEF89}"/>
-              </a:ext>
-            </a:extLst>
-          </p:cNvPr>
+          <p:cNvPr id="2" name="Title 1"/>
           <p:cNvSpPr>
             <a:spLocks noGrp="1"/>
           </p:cNvSpPr>
@@ -2488,34 +2345,29 @@
         </p:nvSpPr>
         <p:spPr>
           <a:xfrm>
-            <a:off x="839788" y="457200"/>
-            <a:ext cx="3932237" cy="1600200"/>
+            <a:off x="1792288" y="4800600"/>
+            <a:ext cx="5486400" cy="566738"/>
           </a:xfrm>
         </p:spPr>
         <p:txBody>
           <a:bodyPr anchor="b"/>
           <a:lstStyle>
-            <a:lvl1pPr>
-              <a:defRPr sz="3200"/>
+            <a:lvl1pPr algn="l">
+              <a:defRPr sz="2000" b="1"/>
             </a:lvl1pPr>
           </a:lstStyle>
           <a:p>
             <a:r>
-              <a:rPr lang="en-US"/>
+              <a:rPr lang="en-US" smtClean="0"/>
               <a:t>Click to edit Master title style</a:t>
             </a:r>
-          </a:p>
-        </p:txBody>
-      </p:sp>
-      <p:sp>
-        <p:nvSpPr>
-          <p:cNvPr id="3" name="Picture Placeholder 2">
-            <a:extLst>
-              <a:ext uri="{FF2B5EF4-FFF2-40B4-BE49-F238E27FC236}">
-                <a16:creationId xmlns:a16="http://schemas.microsoft.com/office/drawing/2014/main" id="{F1ABF5FF-818D-4D22-FB56-39E985F8C2B6}"/>
-              </a:ext>
-            </a:extLst>
-          </p:cNvPr>
+            <a:endParaRPr lang="en-US"/>
+          </a:p>
+        </p:txBody>
+      </p:sp>
+      <p:sp>
+        <p:nvSpPr>
+          <p:cNvPr id="3" name="Picture Placeholder 2"/>
           <p:cNvSpPr>
             <a:spLocks noGrp="1"/>
           </p:cNvSpPr>
@@ -2525,8 +2377,8 @@
         </p:nvSpPr>
         <p:spPr>
           <a:xfrm>
-            <a:off x="5183188" y="987425"/>
-            <a:ext cx="6172200" cy="4873625"/>
+            <a:off x="1792288" y="612775"/>
+            <a:ext cx="5486400" cy="4114800"/>
           </a:xfrm>
         </p:spPr>
         <p:txBody>
@@ -2576,13 +2428,7 @@
       </p:sp>
       <p:sp>
         <p:nvSpPr>
-          <p:cNvPr id="4" name="Text Placeholder 3">
-            <a:extLst>
-              <a:ext uri="{FF2B5EF4-FFF2-40B4-BE49-F238E27FC236}">
-                <a16:creationId xmlns:a16="http://schemas.microsoft.com/office/drawing/2014/main" id="{35F2E1F7-52AC-ACDF-480D-03031C0B23FB}"/>
-              </a:ext>
-            </a:extLst>
-          </p:cNvPr>
+          <p:cNvPr id="4" name="Text Placeholder 3"/>
           <p:cNvSpPr>
             <a:spLocks noGrp="1"/>
           </p:cNvSpPr>
@@ -2592,8 +2438,8 @@
         </p:nvSpPr>
         <p:spPr>
           <a:xfrm>
-            <a:off x="839788" y="2057400"/>
-            <a:ext cx="3932237" cy="3811588"/>
+            <a:off x="1792288" y="5367338"/>
+            <a:ext cx="5486400" cy="804862"/>
           </a:xfrm>
         </p:spPr>
         <p:txBody>
@@ -2601,45 +2447,45 @@
           <a:lstStyle>
             <a:lvl1pPr marL="0" indent="0">
               <a:buNone/>
-              <a:defRPr sz="1600"/>
+              <a:defRPr sz="1400"/>
             </a:lvl1pPr>
             <a:lvl2pPr marL="457200" indent="0">
               <a:buNone/>
-              <a:defRPr sz="1400"/>
+              <a:defRPr sz="1200"/>
             </a:lvl2pPr>
             <a:lvl3pPr marL="914400" indent="0">
               <a:buNone/>
-              <a:defRPr sz="1200"/>
+              <a:defRPr sz="1000"/>
             </a:lvl3pPr>
             <a:lvl4pPr marL="1371600" indent="0">
               <a:buNone/>
-              <a:defRPr sz="1000"/>
+              <a:defRPr sz="900"/>
             </a:lvl4pPr>
             <a:lvl5pPr marL="1828800" indent="0">
               <a:buNone/>
-              <a:defRPr sz="1000"/>
+              <a:defRPr sz="900"/>
             </a:lvl5pPr>
             <a:lvl6pPr marL="2286000" indent="0">
               <a:buNone/>
-              <a:defRPr sz="1000"/>
+              <a:defRPr sz="900"/>
             </a:lvl6pPr>
             <a:lvl7pPr marL="2743200" indent="0">
               <a:buNone/>
-              <a:defRPr sz="1000"/>
+              <a:defRPr sz="900"/>
             </a:lvl7pPr>
             <a:lvl8pPr marL="3200400" indent="0">
               <a:buNone/>
-              <a:defRPr sz="1000"/>
+              <a:defRPr sz="900"/>
             </a:lvl8pPr>
             <a:lvl9pPr marL="3657600" indent="0">
               <a:buNone/>
-              <a:defRPr sz="1000"/>
+              <a:defRPr sz="900"/>
             </a:lvl9pPr>
           </a:lstStyle>
           <a:p>
             <a:pPr lvl="0"/>
             <a:r>
-              <a:rPr lang="en-US"/>
+              <a:rPr lang="en-US" smtClean="0"/>
               <a:t>Click to edit Master text styles</a:t>
             </a:r>
           </a:p>
@@ -2647,13 +2493,7 @@
       </p:sp>
       <p:sp>
         <p:nvSpPr>
-          <p:cNvPr id="5" name="Date Placeholder 4">
-            <a:extLst>
-              <a:ext uri="{FF2B5EF4-FFF2-40B4-BE49-F238E27FC236}">
-                <a16:creationId xmlns:a16="http://schemas.microsoft.com/office/drawing/2014/main" id="{5ABF3499-FF5D-FD3E-69F8-238F6779C31F}"/>
-              </a:ext>
-            </a:extLst>
-          </p:cNvPr>
+          <p:cNvPr id="5" name="Date Placeholder 4"/>
           <p:cNvSpPr>
             <a:spLocks noGrp="1"/>
           </p:cNvSpPr>
@@ -2666,9 +2506,9 @@
           <a:bodyPr/>
           <a:lstStyle/>
           <a:p>
-            <a:fld id="{77728346-2AB5-1B41-BB29-9C38D3698713}" type="datetimeFigureOut">
-              <a:rPr lang="en-US" smtClean="0"/>
-              <a:t>11/20/25</a:t>
+            <a:fld id="{5BCAD085-E8A6-8845-BD4E-CB4CCA059FC4}" type="datetimeFigureOut">
+              <a:rPr lang="en-US" smtClean="0"/>
+              <a:t>1/27/13</a:t>
             </a:fld>
             <a:endParaRPr lang="en-US"/>
           </a:p>
@@ -2676,13 +2516,7 @@
       </p:sp>
       <p:sp>
         <p:nvSpPr>
-          <p:cNvPr id="6" name="Footer Placeholder 5">
-            <a:extLst>
-              <a:ext uri="{FF2B5EF4-FFF2-40B4-BE49-F238E27FC236}">
-                <a16:creationId xmlns:a16="http://schemas.microsoft.com/office/drawing/2014/main" id="{77F40D47-4250-9A90-260A-F3E661BE4756}"/>
-              </a:ext>
-            </a:extLst>
-          </p:cNvPr>
+          <p:cNvPr id="6" name="Footer Placeholder 5"/>
           <p:cNvSpPr>
             <a:spLocks noGrp="1"/>
           </p:cNvSpPr>
@@ -2701,13 +2535,7 @@
       </p:sp>
       <p:sp>
         <p:nvSpPr>
-          <p:cNvPr id="7" name="Slide Number Placeholder 6">
-            <a:extLst>
-              <a:ext uri="{FF2B5EF4-FFF2-40B4-BE49-F238E27FC236}">
-                <a16:creationId xmlns:a16="http://schemas.microsoft.com/office/drawing/2014/main" id="{764B1A5D-C626-A6BB-A387-67DF2F00ABEE}"/>
-              </a:ext>
-            </a:extLst>
-          </p:cNvPr>
+          <p:cNvPr id="7" name="Slide Number Placeholder 6"/>
           <p:cNvSpPr>
             <a:spLocks noGrp="1"/>
           </p:cNvSpPr>
@@ -2720,7 +2548,7 @@
           <a:bodyPr/>
           <a:lstStyle/>
           <a:p>
-            <a:fld id="{3DE4617C-001E-1047-A50C-4774964ACBA9}" type="slidenum">
+            <a:fld id="{C1FF6DA9-008F-8B48-92A6-B652298478BF}" type="slidenum">
               <a:rPr lang="en-US" smtClean="0"/>
               <a:t>‹#›</a:t>
             </a:fld>
@@ -2731,7 +2559,7 @@
     </p:spTree>
     <p:extLst>
       <p:ext uri="{BB962C8B-B14F-4D97-AF65-F5344CB8AC3E}">
-        <p14:creationId xmlns:p14="http://schemas.microsoft.com/office/powerpoint/2010/main" val="3775638218"/>
+        <p14:creationId xmlns:p14="http://schemas.microsoft.com/office/powerpoint/2010/main" val="3889236939"/>
       </p:ext>
     </p:extLst>
   </p:cSld>
@@ -2765,13 +2593,7 @@
       </p:grpSpPr>
       <p:sp>
         <p:nvSpPr>
-          <p:cNvPr id="2" name="Title Placeholder 1">
-            <a:extLst>
-              <a:ext uri="{FF2B5EF4-FFF2-40B4-BE49-F238E27FC236}">
-                <a16:creationId xmlns:a16="http://schemas.microsoft.com/office/drawing/2014/main" id="{5BFC1428-6D2A-DD37-1C4C-BBB162E34290}"/>
-              </a:ext>
-            </a:extLst>
-          </p:cNvPr>
+          <p:cNvPr id="2" name="Title Placeholder 1"/>
           <p:cNvSpPr>
             <a:spLocks noGrp="1"/>
           </p:cNvSpPr>
@@ -2781,8 +2603,8 @@
         </p:nvSpPr>
         <p:spPr>
           <a:xfrm>
-            <a:off x="838200" y="365125"/>
-            <a:ext cx="10515600" cy="1325563"/>
+            <a:off x="457200" y="274638"/>
+            <a:ext cx="8229600" cy="1143000"/>
           </a:xfrm>
           <a:prstGeom prst="rect">
             <a:avLst/>
@@ -2795,21 +2617,16 @@
           <a:lstStyle/>
           <a:p>
             <a:r>
-              <a:rPr lang="en-US"/>
+              <a:rPr lang="en-US" smtClean="0"/>
               <a:t>Click to edit Master title style</a:t>
             </a:r>
-          </a:p>
-        </p:txBody>
-      </p:sp>
-      <p:sp>
-        <p:nvSpPr>
-          <p:cNvPr id="3" name="Text Placeholder 2">
-            <a:extLst>
-              <a:ext uri="{FF2B5EF4-FFF2-40B4-BE49-F238E27FC236}">
-                <a16:creationId xmlns:a16="http://schemas.microsoft.com/office/drawing/2014/main" id="{FBE33447-2DB2-E440-B9C1-C8A3B78F003C}"/>
-              </a:ext>
-            </a:extLst>
-          </p:cNvPr>
+            <a:endParaRPr lang="en-US"/>
+          </a:p>
+        </p:txBody>
+      </p:sp>
+      <p:sp>
+        <p:nvSpPr>
+          <p:cNvPr id="3" name="Text Placeholder 2"/>
           <p:cNvSpPr>
             <a:spLocks noGrp="1"/>
           </p:cNvSpPr>
@@ -2819,8 +2636,8 @@
         </p:nvSpPr>
         <p:spPr>
           <a:xfrm>
-            <a:off x="838200" y="1825625"/>
-            <a:ext cx="10515600" cy="4351338"/>
+            <a:off x="457200" y="1600200"/>
+            <a:ext cx="8229600" cy="4525963"/>
           </a:xfrm>
           <a:prstGeom prst="rect">
             <a:avLst/>
@@ -2834,49 +2651,44 @@
           <a:p>
             <a:pPr lvl="0"/>
             <a:r>
-              <a:rPr lang="en-US"/>
+              <a:rPr lang="en-US" smtClean="0"/>
               <a:t>Click to edit Master text styles</a:t>
             </a:r>
           </a:p>
           <a:p>
             <a:pPr lvl="1"/>
             <a:r>
-              <a:rPr lang="en-US"/>
+              <a:rPr lang="en-US" smtClean="0"/>
               <a:t>Second level</a:t>
             </a:r>
           </a:p>
           <a:p>
             <a:pPr lvl="2"/>
             <a:r>
-              <a:rPr lang="en-US"/>
+              <a:rPr lang="en-US" smtClean="0"/>
               <a:t>Third level</a:t>
             </a:r>
           </a:p>
           <a:p>
             <a:pPr lvl="3"/>
             <a:r>
-              <a:rPr lang="en-US"/>
+              <a:rPr lang="en-US" smtClean="0"/>
               <a:t>Fourth level</a:t>
             </a:r>
           </a:p>
           <a:p>
             <a:pPr lvl="4"/>
             <a:r>
-              <a:rPr lang="en-US"/>
+              <a:rPr lang="en-US" smtClean="0"/>
               <a:t>Fifth level</a:t>
             </a:r>
-          </a:p>
-        </p:txBody>
-      </p:sp>
-      <p:sp>
-        <p:nvSpPr>
-          <p:cNvPr id="4" name="Date Placeholder 3">
-            <a:extLst>
-              <a:ext uri="{FF2B5EF4-FFF2-40B4-BE49-F238E27FC236}">
-                <a16:creationId xmlns:a16="http://schemas.microsoft.com/office/drawing/2014/main" id="{22BD55D2-8AB2-4DA8-CA91-A3FDA163C5C7}"/>
-              </a:ext>
-            </a:extLst>
-          </p:cNvPr>
+            <a:endParaRPr lang="en-US"/>
+          </a:p>
+        </p:txBody>
+      </p:sp>
+      <p:sp>
+        <p:nvSpPr>
+          <p:cNvPr id="4" name="Date Placeholder 3"/>
           <p:cNvSpPr>
             <a:spLocks noGrp="1"/>
           </p:cNvSpPr>
@@ -2886,8 +2698,8 @@
         </p:nvSpPr>
         <p:spPr>
           <a:xfrm>
-            <a:off x="838200" y="6356350"/>
-            <a:ext cx="2743200" cy="365125"/>
+            <a:off x="457200" y="6356350"/>
+            <a:ext cx="2133600" cy="365125"/>
           </a:xfrm>
           <a:prstGeom prst="rect">
             <a:avLst/>
@@ -2900,16 +2712,16 @@
               <a:defRPr sz="1200">
                 <a:solidFill>
                   <a:schemeClr val="tx1">
-                    <a:tint val="82000"/>
+                    <a:tint val="75000"/>
                   </a:schemeClr>
                 </a:solidFill>
               </a:defRPr>
             </a:lvl1pPr>
           </a:lstStyle>
           <a:p>
-            <a:fld id="{77728346-2AB5-1B41-BB29-9C38D3698713}" type="datetimeFigureOut">
-              <a:rPr lang="en-US" smtClean="0"/>
-              <a:t>11/20/25</a:t>
+            <a:fld id="{5BCAD085-E8A6-8845-BD4E-CB4CCA059FC4}" type="datetimeFigureOut">
+              <a:rPr lang="en-US" smtClean="0"/>
+              <a:t>1/27/13</a:t>
             </a:fld>
             <a:endParaRPr lang="en-US"/>
           </a:p>
@@ -2917,13 +2729,7 @@
       </p:sp>
       <p:sp>
         <p:nvSpPr>
-          <p:cNvPr id="5" name="Footer Placeholder 4">
-            <a:extLst>
-              <a:ext uri="{FF2B5EF4-FFF2-40B4-BE49-F238E27FC236}">
-                <a16:creationId xmlns:a16="http://schemas.microsoft.com/office/drawing/2014/main" id="{73E7000B-D60C-26CF-D368-650C7FE20603}"/>
-              </a:ext>
-            </a:extLst>
-          </p:cNvPr>
+          <p:cNvPr id="5" name="Footer Placeholder 4"/>
           <p:cNvSpPr>
             <a:spLocks noGrp="1"/>
           </p:cNvSpPr>
@@ -2933,8 +2739,8 @@
         </p:nvSpPr>
         <p:spPr>
           <a:xfrm>
-            <a:off x="4038600" y="6356350"/>
-            <a:ext cx="4114800" cy="365125"/>
+            <a:off x="3124200" y="6356350"/>
+            <a:ext cx="2895600" cy="365125"/>
           </a:xfrm>
           <a:prstGeom prst="rect">
             <a:avLst/>
@@ -2947,7 +2753,7 @@
               <a:defRPr sz="1200">
                 <a:solidFill>
                   <a:schemeClr val="tx1">
-                    <a:tint val="82000"/>
+                    <a:tint val="75000"/>
                   </a:schemeClr>
                 </a:solidFill>
               </a:defRPr>
@@ -2960,13 +2766,7 @@
       </p:sp>
       <p:sp>
         <p:nvSpPr>
-          <p:cNvPr id="6" name="Slide Number Placeholder 5">
-            <a:extLst>
-              <a:ext uri="{FF2B5EF4-FFF2-40B4-BE49-F238E27FC236}">
-                <a16:creationId xmlns:a16="http://schemas.microsoft.com/office/drawing/2014/main" id="{FCE86C8A-1CD2-FB20-48B5-AF1315014452}"/>
-              </a:ext>
-            </a:extLst>
-          </p:cNvPr>
+          <p:cNvPr id="6" name="Slide Number Placeholder 5"/>
           <p:cNvSpPr>
             <a:spLocks noGrp="1"/>
           </p:cNvSpPr>
@@ -2976,8 +2776,8 @@
         </p:nvSpPr>
         <p:spPr>
           <a:xfrm>
-            <a:off x="8610600" y="6356350"/>
-            <a:ext cx="2743200" cy="365125"/>
+            <a:off x="6553200" y="6356350"/>
+            <a:ext cx="2133600" cy="365125"/>
           </a:xfrm>
           <a:prstGeom prst="rect">
             <a:avLst/>
@@ -2990,14 +2790,14 @@
               <a:defRPr sz="1200">
                 <a:solidFill>
                   <a:schemeClr val="tx1">
-                    <a:tint val="82000"/>
+                    <a:tint val="75000"/>
                   </a:schemeClr>
                 </a:solidFill>
               </a:defRPr>
             </a:lvl1pPr>
           </a:lstStyle>
           <a:p>
-            <a:fld id="{3DE4617C-001E-1047-A50C-4774964ACBA9}" type="slidenum">
+            <a:fld id="{C1FF6DA9-008F-8B48-92A6-B652298478BF}" type="slidenum">
               <a:rPr lang="en-US" smtClean="0"/>
               <a:t>‹#›</a:t>
             </a:fld>
@@ -3008,7 +2808,7 @@
     </p:spTree>
     <p:extLst>
       <p:ext uri="{BB962C8B-B14F-4D97-AF65-F5344CB8AC3E}">
-        <p14:creationId xmlns:p14="http://schemas.microsoft.com/office/powerpoint/2010/main" val="2475398114"/>
+        <p14:creationId xmlns:p14="http://schemas.microsoft.com/office/powerpoint/2010/main" val="2209977519"/>
       </p:ext>
     </p:extLst>
   </p:cSld>
@@ -3028,10 +2828,7 @@
   </p:sldLayoutIdLst>
   <p:txStyles>
     <p:titleStyle>
-      <a:lvl1pPr algn="l" defTabSz="914400" rtl="0" eaLnBrk="1" latinLnBrk="0" hangingPunct="1">
-        <a:lnSpc>
-          <a:spcPct val="90000"/>
-        </a:lnSpc>
+      <a:lvl1pPr algn="ctr" defTabSz="457200" rtl="0" eaLnBrk="1" latinLnBrk="0" hangingPunct="1">
         <a:spcBef>
           <a:spcPct val="0"/>
         </a:spcBef>
@@ -3047,15 +2844,27 @@
       </a:lvl1pPr>
     </p:titleStyle>
     <p:bodyStyle>
-      <a:lvl1pPr marL="228600" indent="-228600" algn="l" defTabSz="914400" rtl="0" eaLnBrk="1" latinLnBrk="0" hangingPunct="1">
-        <a:lnSpc>
-          <a:spcPct val="90000"/>
-        </a:lnSpc>
+      <a:lvl1pPr marL="342900" indent="-342900" algn="l" defTabSz="457200" rtl="0" eaLnBrk="1" latinLnBrk="0" hangingPunct="1">
         <a:spcBef>
-          <a:spcPts val="1000"/>
+          <a:spcPct val="20000"/>
         </a:spcBef>
-        <a:buFont typeface="Arial" panose="020B0604020202020204" pitchFamily="34" charset="0"/>
+        <a:buFont typeface="Arial"/>
         <a:buChar char="•"/>
+        <a:defRPr sz="3200" kern="1200">
+          <a:solidFill>
+            <a:schemeClr val="tx1"/>
+          </a:solidFill>
+          <a:latin typeface="+mn-lt"/>
+          <a:ea typeface="+mn-ea"/>
+          <a:cs typeface="+mn-cs"/>
+        </a:defRPr>
+      </a:lvl1pPr>
+      <a:lvl2pPr marL="742950" indent="-285750" algn="l" defTabSz="457200" rtl="0" eaLnBrk="1" latinLnBrk="0" hangingPunct="1">
+        <a:spcBef>
+          <a:spcPct val="20000"/>
+        </a:spcBef>
+        <a:buFont typeface="Arial"/>
+        <a:buChar char="–"/>
         <a:defRPr sz="2800" kern="1200">
           <a:solidFill>
             <a:schemeClr val="tx1"/>
@@ -3064,15 +2873,12 @@
           <a:ea typeface="+mn-ea"/>
           <a:cs typeface="+mn-cs"/>
         </a:defRPr>
-      </a:lvl1pPr>
-      <a:lvl2pPr marL="685800" indent="-228600" algn="l" defTabSz="914400" rtl="0" eaLnBrk="1" latinLnBrk="0" hangingPunct="1">
-        <a:lnSpc>
-          <a:spcPct val="90000"/>
-        </a:lnSpc>
+      </a:lvl2pPr>
+      <a:lvl3pPr marL="1143000" indent="-228600" algn="l" defTabSz="457200" rtl="0" eaLnBrk="1" latinLnBrk="0" hangingPunct="1">
         <a:spcBef>
-          <a:spcPts val="500"/>
+          <a:spcPct val="20000"/>
         </a:spcBef>
-        <a:buFont typeface="Arial" panose="020B0604020202020204" pitchFamily="34" charset="0"/>
+        <a:buFont typeface="Arial"/>
         <a:buChar char="•"/>
         <a:defRPr sz="2400" kern="1200">
           <a:solidFill>
@@ -3082,15 +2888,42 @@
           <a:ea typeface="+mn-ea"/>
           <a:cs typeface="+mn-cs"/>
         </a:defRPr>
-      </a:lvl2pPr>
-      <a:lvl3pPr marL="1143000" indent="-228600" algn="l" defTabSz="914400" rtl="0" eaLnBrk="1" latinLnBrk="0" hangingPunct="1">
-        <a:lnSpc>
-          <a:spcPct val="90000"/>
-        </a:lnSpc>
+      </a:lvl3pPr>
+      <a:lvl4pPr marL="1600200" indent="-228600" algn="l" defTabSz="457200" rtl="0" eaLnBrk="1" latinLnBrk="0" hangingPunct="1">
         <a:spcBef>
-          <a:spcPts val="500"/>
+          <a:spcPct val="20000"/>
         </a:spcBef>
-        <a:buFont typeface="Arial" panose="020B0604020202020204" pitchFamily="34" charset="0"/>
+        <a:buFont typeface="Arial"/>
+        <a:buChar char="–"/>
+        <a:defRPr sz="2000" kern="1200">
+          <a:solidFill>
+            <a:schemeClr val="tx1"/>
+          </a:solidFill>
+          <a:latin typeface="+mn-lt"/>
+          <a:ea typeface="+mn-ea"/>
+          <a:cs typeface="+mn-cs"/>
+        </a:defRPr>
+      </a:lvl4pPr>
+      <a:lvl5pPr marL="2057400" indent="-228600" algn="l" defTabSz="457200" rtl="0" eaLnBrk="1" latinLnBrk="0" hangingPunct="1">
+        <a:spcBef>
+          <a:spcPct val="20000"/>
+        </a:spcBef>
+        <a:buFont typeface="Arial"/>
+        <a:buChar char="»"/>
+        <a:defRPr sz="2000" kern="1200">
+          <a:solidFill>
+            <a:schemeClr val="tx1"/>
+          </a:solidFill>
+          <a:latin typeface="+mn-lt"/>
+          <a:ea typeface="+mn-ea"/>
+          <a:cs typeface="+mn-cs"/>
+        </a:defRPr>
+      </a:lvl5pPr>
+      <a:lvl6pPr marL="2514600" indent="-228600" algn="l" defTabSz="457200" rtl="0" eaLnBrk="1" latinLnBrk="0" hangingPunct="1">
+        <a:spcBef>
+          <a:spcPct val="20000"/>
+        </a:spcBef>
+        <a:buFont typeface="Arial"/>
         <a:buChar char="•"/>
         <a:defRPr sz="2000" kern="1200">
           <a:solidFill>
@@ -3100,71 +2933,14 @@
           <a:ea typeface="+mn-ea"/>
           <a:cs typeface="+mn-cs"/>
         </a:defRPr>
-      </a:lvl3pPr>
-      <a:lvl4pPr marL="1600200" indent="-228600" algn="l" defTabSz="914400" rtl="0" eaLnBrk="1" latinLnBrk="0" hangingPunct="1">
-        <a:lnSpc>
-          <a:spcPct val="90000"/>
-        </a:lnSpc>
+      </a:lvl6pPr>
+      <a:lvl7pPr marL="2971800" indent="-228600" algn="l" defTabSz="457200" rtl="0" eaLnBrk="1" latinLnBrk="0" hangingPunct="1">
         <a:spcBef>
-          <a:spcPts val="500"/>
+          <a:spcPct val="20000"/>
         </a:spcBef>
-        <a:buFont typeface="Arial" panose="020B0604020202020204" pitchFamily="34" charset="0"/>
+        <a:buFont typeface="Arial"/>
         <a:buChar char="•"/>
-        <a:defRPr sz="1800" kern="1200">
-          <a:solidFill>
-            <a:schemeClr val="tx1"/>
-          </a:solidFill>
-          <a:latin typeface="+mn-lt"/>
-          <a:ea typeface="+mn-ea"/>
-          <a:cs typeface="+mn-cs"/>
-        </a:defRPr>
-      </a:lvl4pPr>
-      <a:lvl5pPr marL="2057400" indent="-228600" algn="l" defTabSz="914400" rtl="0" eaLnBrk="1" latinLnBrk="0" hangingPunct="1">
-        <a:lnSpc>
-          <a:spcPct val="90000"/>
-        </a:lnSpc>
-        <a:spcBef>
-          <a:spcPts val="500"/>
-        </a:spcBef>
-        <a:buFont typeface="Arial" panose="020B0604020202020204" pitchFamily="34" charset="0"/>
-        <a:buChar char="•"/>
-        <a:defRPr sz="1800" kern="1200">
-          <a:solidFill>
-            <a:schemeClr val="tx1"/>
-          </a:solidFill>
-          <a:latin typeface="+mn-lt"/>
-          <a:ea typeface="+mn-ea"/>
-          <a:cs typeface="+mn-cs"/>
-        </a:defRPr>
-      </a:lvl5pPr>
-      <a:lvl6pPr marL="2514600" indent="-228600" algn="l" defTabSz="914400" rtl="0" eaLnBrk="1" latinLnBrk="0" hangingPunct="1">
-        <a:lnSpc>
-          <a:spcPct val="90000"/>
-        </a:lnSpc>
-        <a:spcBef>
-          <a:spcPts val="500"/>
-        </a:spcBef>
-        <a:buFont typeface="Arial" panose="020B0604020202020204" pitchFamily="34" charset="0"/>
-        <a:buChar char="•"/>
-        <a:defRPr sz="1800" kern="1200">
-          <a:solidFill>
-            <a:schemeClr val="tx1"/>
-          </a:solidFill>
-          <a:latin typeface="+mn-lt"/>
-          <a:ea typeface="+mn-ea"/>
-          <a:cs typeface="+mn-cs"/>
-        </a:defRPr>
-      </a:lvl6pPr>
-      <a:lvl7pPr marL="2971800" indent="-228600" algn="l" defTabSz="914400" rtl="0" eaLnBrk="1" latinLnBrk="0" hangingPunct="1">
-        <a:lnSpc>
-          <a:spcPct val="90000"/>
-        </a:lnSpc>
-        <a:spcBef>
-          <a:spcPts val="500"/>
-        </a:spcBef>
-        <a:buFont typeface="Arial" panose="020B0604020202020204" pitchFamily="34" charset="0"/>
-        <a:buChar char="•"/>
-        <a:defRPr sz="1800" kern="1200">
+        <a:defRPr sz="2000" kern="1200">
           <a:solidFill>
             <a:schemeClr val="tx1"/>
           </a:solidFill>
@@ -3173,16 +2949,13 @@
           <a:cs typeface="+mn-cs"/>
         </a:defRPr>
       </a:lvl7pPr>
-      <a:lvl8pPr marL="3429000" indent="-228600" algn="l" defTabSz="914400" rtl="0" eaLnBrk="1" latinLnBrk="0" hangingPunct="1">
-        <a:lnSpc>
-          <a:spcPct val="90000"/>
-        </a:lnSpc>
+      <a:lvl8pPr marL="3429000" indent="-228600" algn="l" defTabSz="457200" rtl="0" eaLnBrk="1" latinLnBrk="0" hangingPunct="1">
         <a:spcBef>
-          <a:spcPts val="500"/>
+          <a:spcPct val="20000"/>
         </a:spcBef>
-        <a:buFont typeface="Arial" panose="020B0604020202020204" pitchFamily="34" charset="0"/>
+        <a:buFont typeface="Arial"/>
         <a:buChar char="•"/>
-        <a:defRPr sz="1800" kern="1200">
+        <a:defRPr sz="2000" kern="1200">
           <a:solidFill>
             <a:schemeClr val="tx1"/>
           </a:solidFill>
@@ -3191,16 +2964,13 @@
           <a:cs typeface="+mn-cs"/>
         </a:defRPr>
       </a:lvl8pPr>
-      <a:lvl9pPr marL="3886200" indent="-228600" algn="l" defTabSz="914400" rtl="0" eaLnBrk="1" latinLnBrk="0" hangingPunct="1">
-        <a:lnSpc>
-          <a:spcPct val="90000"/>
-        </a:lnSpc>
+      <a:lvl9pPr marL="3886200" indent="-228600" algn="l" defTabSz="457200" rtl="0" eaLnBrk="1" latinLnBrk="0" hangingPunct="1">
         <a:spcBef>
-          <a:spcPts val="500"/>
+          <a:spcPct val="20000"/>
         </a:spcBef>
-        <a:buFont typeface="Arial" panose="020B0604020202020204" pitchFamily="34" charset="0"/>
+        <a:buFont typeface="Arial"/>
         <a:buChar char="•"/>
-        <a:defRPr sz="1800" kern="1200">
+        <a:defRPr sz="2000" kern="1200">
           <a:solidFill>
             <a:schemeClr val="tx1"/>
           </a:solidFill>
@@ -3214,7 +2984,7 @@
       <a:defPPr>
         <a:defRPr lang="en-US"/>
       </a:defPPr>
-      <a:lvl1pPr marL="0" algn="l" defTabSz="914400" rtl="0" eaLnBrk="1" latinLnBrk="0" hangingPunct="1">
+      <a:lvl1pPr marL="0" algn="l" defTabSz="457200" rtl="0" eaLnBrk="1" latinLnBrk="0" hangingPunct="1">
         <a:defRPr sz="1800" kern="1200">
           <a:solidFill>
             <a:schemeClr val="tx1"/>
@@ -3224,7 +2994,7 @@
           <a:cs typeface="+mn-cs"/>
         </a:defRPr>
       </a:lvl1pPr>
-      <a:lvl2pPr marL="457200" algn="l" defTabSz="914400" rtl="0" eaLnBrk="1" latinLnBrk="0" hangingPunct="1">
+      <a:lvl2pPr marL="457200" algn="l" defTabSz="457200" rtl="0" eaLnBrk="1" latinLnBrk="0" hangingPunct="1">
         <a:defRPr sz="1800" kern="1200">
           <a:solidFill>
             <a:schemeClr val="tx1"/>
@@ -3234,7 +3004,7 @@
           <a:cs typeface="+mn-cs"/>
         </a:defRPr>
       </a:lvl2pPr>
-      <a:lvl3pPr marL="914400" algn="l" defTabSz="914400" rtl="0" eaLnBrk="1" latinLnBrk="0" hangingPunct="1">
+      <a:lvl3pPr marL="914400" algn="l" defTabSz="457200" rtl="0" eaLnBrk="1" latinLnBrk="0" hangingPunct="1">
         <a:defRPr sz="1800" kern="1200">
           <a:solidFill>
             <a:schemeClr val="tx1"/>
@@ -3244,7 +3014,7 @@
           <a:cs typeface="+mn-cs"/>
         </a:defRPr>
       </a:lvl3pPr>
-      <a:lvl4pPr marL="1371600" algn="l" defTabSz="914400" rtl="0" eaLnBrk="1" latinLnBrk="0" hangingPunct="1">
+      <a:lvl4pPr marL="1371600" algn="l" defTabSz="457200" rtl="0" eaLnBrk="1" latinLnBrk="0" hangingPunct="1">
         <a:defRPr sz="1800" kern="1200">
           <a:solidFill>
             <a:schemeClr val="tx1"/>
@@ -3254,7 +3024,7 @@
           <a:cs typeface="+mn-cs"/>
         </a:defRPr>
       </a:lvl4pPr>
-      <a:lvl5pPr marL="1828800" algn="l" defTabSz="914400" rtl="0" eaLnBrk="1" latinLnBrk="0" hangingPunct="1">
+      <a:lvl5pPr marL="1828800" algn="l" defTabSz="457200" rtl="0" eaLnBrk="1" latinLnBrk="0" hangingPunct="1">
         <a:defRPr sz="1800" kern="1200">
           <a:solidFill>
             <a:schemeClr val="tx1"/>
@@ -3264,7 +3034,7 @@
           <a:cs typeface="+mn-cs"/>
         </a:defRPr>
       </a:lvl5pPr>
-      <a:lvl6pPr marL="2286000" algn="l" defTabSz="914400" rtl="0" eaLnBrk="1" latinLnBrk="0" hangingPunct="1">
+      <a:lvl6pPr marL="2286000" algn="l" defTabSz="457200" rtl="0" eaLnBrk="1" latinLnBrk="0" hangingPunct="1">
         <a:defRPr sz="1800" kern="1200">
           <a:solidFill>
             <a:schemeClr val="tx1"/>
@@ -3274,7 +3044,7 @@
           <a:cs typeface="+mn-cs"/>
         </a:defRPr>
       </a:lvl6pPr>
-      <a:lvl7pPr marL="2743200" algn="l" defTabSz="914400" rtl="0" eaLnBrk="1" latinLnBrk="0" hangingPunct="1">
+      <a:lvl7pPr marL="2743200" algn="l" defTabSz="457200" rtl="0" eaLnBrk="1" latinLnBrk="0" hangingPunct="1">
         <a:defRPr sz="1800" kern="1200">
           <a:solidFill>
             <a:schemeClr val="tx1"/>
@@ -3284,7 +3054,7 @@
           <a:cs typeface="+mn-cs"/>
         </a:defRPr>
       </a:lvl7pPr>
-      <a:lvl8pPr marL="3200400" algn="l" defTabSz="914400" rtl="0" eaLnBrk="1" latinLnBrk="0" hangingPunct="1">
+      <a:lvl8pPr marL="3200400" algn="l" defTabSz="457200" rtl="0" eaLnBrk="1" latinLnBrk="0" hangingPunct="1">
         <a:defRPr sz="1800" kern="1200">
           <a:solidFill>
             <a:schemeClr val="tx1"/>
@@ -3294,7 +3064,7 @@
           <a:cs typeface="+mn-cs"/>
         </a:defRPr>
       </a:lvl8pPr>
-      <a:lvl9pPr marL="3657600" algn="l" defTabSz="914400" rtl="0" eaLnBrk="1" latinLnBrk="0" hangingPunct="1">
+      <a:lvl9pPr marL="3657600" algn="l" defTabSz="457200" rtl="0" eaLnBrk="1" latinLnBrk="0" hangingPunct="1">
         <a:defRPr sz="1800" kern="1200">
           <a:solidFill>
             <a:schemeClr val="tx1"/>
@@ -3310,7 +3080,7 @@
 </file>
 
 <file path=ppt/slides/slide1.xml><?xml version="1.0" encoding="utf-8"?>
-<p:sld xmlns:a="http://schemas.openxmlformats.org/drawingml/2006/main" xmlns:r="http://schemas.openxmlformats.org/officeDocument/2006/relationships" xmlns:p="http://schemas.openxmlformats.org/presentationml/2006/main">
+<p:sld xmlns:a="http://schemas.openxmlformats.org/drawingml/2006/main" xmlns:p="http://schemas.openxmlformats.org/presentationml/2006/main" xmlns:r="http://schemas.openxmlformats.org/officeDocument/2006/relationships">
   <p:cSld>
     <p:spTree>
       <p:nvGrpSpPr>
@@ -3318,38 +3088,33 @@
         <p:cNvGrpSpPr/>
         <p:nvPr/>
       </p:nvGrpSpPr>
-      <p:grpSpPr>
-        <a:xfrm>
-          <a:off x="0" y="0"/>
-          <a:ext cx="0" cy="0"/>
-          <a:chOff x="0" y="0"/>
-          <a:chExt cx="0" cy="0"/>
-        </a:xfrm>
-      </p:grpSpPr>
-      <p:sp>
-        <p:nvSpPr>
-          <p:cNvPr id="7" name="Title 6">
-            <a:extLst>
-              <a:ext uri="{FF2B5EF4-FFF2-40B4-BE49-F238E27FC236}">
-                <a16:creationId xmlns:a16="http://schemas.microsoft.com/office/drawing/2014/main" id="{0FBD8ED8-7390-1616-C66A-5289111267E5}"/>
-              </a:ext>
-            </a:extLst>
-          </p:cNvPr>
-          <p:cNvSpPr>
-            <a:spLocks noGrp="1"/>
-          </p:cNvSpPr>
-          <p:nvPr>
-            <p:ph type="title"/>
-          </p:nvPr>
-        </p:nvSpPr>
-        <p:spPr/>
-        <p:txBody>
-          <a:bodyPr/>
-          <a:lstStyle/>
-          <a:p>
-            <a:pPr algn="ctr"/>
-            <a:r>
-              <a:rPr lang="en-US" dirty="0"/>
+      <p:grpSpPr/>
+      <p:sp>
+        <p:nvSpPr>
+          <p:cNvPr id="2" name="TextBox 1"/>
+          <p:cNvSpPr txBox="1"/>
+          <p:nvPr/>
+        </p:nvSpPr>
+        <p:spPr>
+          <a:xfrm>
+            <a:off x="457200" y="182880"/>
+            <a:ext cx="8229600" cy="548640"/>
+          </a:xfrm>
+          <a:prstGeom prst="rect">
+            <a:avLst/>
+          </a:prstGeom>
+          <a:noFill/>
+        </p:spPr>
+        <p:txBody>
+          <a:bodyPr wrap="none">
+            <a:spAutoFit/>
+          </a:bodyPr>
+          <a:lstStyle/>
+          <a:p>
+            <a:pPr>
+              <a:defRPr sz="3200"/>
+            </a:pPr>
+            <a:r>
               <a:t>Open-Source Software</a:t>
             </a:r>
           </a:p>
@@ -3357,100 +3122,238 @@
       </p:sp>
       <p:sp>
         <p:nvSpPr>
-          <p:cNvPr id="8" name="Content Placeholder 7">
-            <a:extLst>
-              <a:ext uri="{FF2B5EF4-FFF2-40B4-BE49-F238E27FC236}">
-                <a16:creationId xmlns:a16="http://schemas.microsoft.com/office/drawing/2014/main" id="{C3B3FCED-64D0-4C16-0F36-30998F102591}"/>
-              </a:ext>
-            </a:extLst>
-          </p:cNvPr>
-          <p:cNvSpPr>
-            <a:spLocks noGrp="1"/>
-          </p:cNvSpPr>
-          <p:nvPr>
-            <p:ph idx="1"/>
-          </p:nvPr>
-        </p:nvSpPr>
-        <p:spPr/>
-        <p:txBody>
-          <a:bodyPr>
-            <a:normAutofit fontScale="77500" lnSpcReduction="20000"/>
+          <p:cNvPr id="3" name="TextBox 2"/>
+          <p:cNvSpPr txBox="1"/>
+          <p:nvPr/>
+        </p:nvSpPr>
+        <p:spPr>
+          <a:xfrm>
+            <a:off x="457200" y="1005840"/>
+            <a:ext cx="3657600" cy="365760"/>
+          </a:xfrm>
+          <a:prstGeom prst="rect">
+            <a:avLst/>
+          </a:prstGeom>
+          <a:noFill/>
+        </p:spPr>
+        <p:txBody>
+          <a:bodyPr wrap="none">
+            <a:spAutoFit/>
           </a:bodyPr>
           <a:lstStyle/>
           <a:p>
-            <a:pPr marL="0" indent="0">
-              <a:buNone/>
+            <a:pPr>
+              <a:defRPr sz="2000"/>
             </a:pPr>
             <a:r>
-              <a:rPr lang="en-US" b="1" dirty="0">
-                <a:solidFill>
-                  <a:srgbClr val="FF0000"/>
-                </a:solidFill>
-              </a:rPr>
               <a:t>Key Benefits:</a:t>
             </a:r>
           </a:p>
-          <a:p>
-            <a:r>
-              <a:rPr lang="en-US" dirty="0"/>
-              <a:t>Open-source software is cost-effective as it eliminates license fees, reducing overall expenses.</a:t>
-            </a:r>
-          </a:p>
-          <a:p>
-            <a:r>
-              <a:rPr lang="en-US" dirty="0"/>
-              <a:t>Ehnhances security and transparency by allowing public access to source code</a:t>
-            </a:r>
-          </a:p>
-          <a:p>
-            <a:r>
-              <a:rPr lang="en-US" dirty="0"/>
-              <a:t>Strong global community improves and maintains open-source projects.</a:t>
-            </a:r>
-          </a:p>
-          <a:p>
-            <a:r>
-              <a:rPr lang="en-US" dirty="0"/>
-              <a:t>Offers flexibility, allowing users to customize and adapt the software</a:t>
-            </a:r>
-          </a:p>
-          <a:p>
-            <a:endParaRPr lang="en-US" dirty="0"/>
-          </a:p>
-          <a:p>
-            <a:pPr marL="0" indent="0">
-              <a:buNone/>
+        </p:txBody>
+      </p:sp>
+      <p:sp>
+        <p:nvSpPr>
+          <p:cNvPr id="4" name="TextBox 3"/>
+          <p:cNvSpPr txBox="1"/>
+          <p:nvPr/>
+        </p:nvSpPr>
+        <p:spPr>
+          <a:xfrm>
+            <a:off x="457200" y="1554480"/>
+            <a:ext cx="8229600" cy="1097280"/>
+          </a:xfrm>
+          <a:prstGeom prst="rect">
+            <a:avLst/>
+          </a:prstGeom>
+          <a:noFill/>
+        </p:spPr>
+        <p:txBody>
+          <a:bodyPr wrap="none">
+            <a:spAutoFit/>
+          </a:bodyPr>
+          <a:lstStyle/>
+          <a:p>
+            <a:pPr>
+              <a:buChar char="•"/>
+              <a:defRPr sz="1800"/>
             </a:pPr>
             <a:r>
-              <a:rPr lang="en-US" b="1">
-                <a:solidFill>
-                  <a:srgbClr val="FF0000"/>
-                </a:solidFill>
-              </a:rPr>
-              <a:t>Considerations When Using Open-Source Software:</a:t>
-            </a:r>
-            <a:endParaRPr lang="en-US" dirty="0"/>
-          </a:p>
-          <a:p>
-            <a:r>
-              <a:rPr lang="en-US" dirty="0"/>
-              <a:t>Open-source projects often rely on community support, which may not be as reliable as dedicated customer service.</a:t>
-            </a:r>
-          </a:p>
-          <a:p>
-            <a:r>
-              <a:rPr lang="en-US" dirty="0"/>
-              <a:t>Some open-source solutions may require advanced technical expertise for implementation and maintenance.</a:t>
+              <a:t>Cost effective</a:t>
+            </a:r>
+          </a:p>
+          <a:p>
+            <a:pPr>
+              <a:buChar char="•"/>
+              <a:defRPr sz="1800"/>
+            </a:pPr>
+            <a:r>
+              <a:t>Transparent community</a:t>
+            </a:r>
+          </a:p>
+        </p:txBody>
+      </p:sp>
+      <p:sp>
+        <p:nvSpPr>
+          <p:cNvPr id="5" name="TextBox 4"/>
+          <p:cNvSpPr txBox="1"/>
+          <p:nvPr/>
+        </p:nvSpPr>
+        <p:spPr>
+          <a:xfrm>
+            <a:off x="457200" y="4114800"/>
+            <a:ext cx="8229600" cy="914400"/>
+          </a:xfrm>
+          <a:prstGeom prst="rect">
+            <a:avLst/>
+          </a:prstGeom>
+          <a:noFill/>
+        </p:spPr>
+        <p:txBody>
+          <a:bodyPr wrap="none">
+            <a:spAutoFit/>
+          </a:bodyPr>
+          <a:lstStyle/>
+          <a:p>
+            <a:pPr>
+              <a:buChar char="•"/>
+              <a:defRPr sz="1800"/>
+            </a:pPr>
+            <a:r>
+              <a:t>Community support can vary</a:t>
+            </a:r>
+          </a:p>
+          <a:p>
+            <a:pPr>
+              <a:buChar char="•"/>
+              <a:defRPr sz="1800"/>
+            </a:pPr>
+            <a:r>
+              <a:t>Maintenance requires expertise</a:t>
+            </a:r>
+          </a:p>
+        </p:txBody>
+      </p:sp>
+      <p:sp>
+        <p:nvSpPr>
+          <p:cNvPr id="6" name="TextBox 5"/>
+          <p:cNvSpPr txBox="1"/>
+          <p:nvPr/>
+        </p:nvSpPr>
+        <p:spPr>
+          <a:xfrm>
+            <a:off x="457200" y="3566160"/>
+            <a:ext cx="4572000" cy="365760"/>
+          </a:xfrm>
+          <a:prstGeom prst="rect">
+            <a:avLst/>
+          </a:prstGeom>
+          <a:noFill/>
+        </p:spPr>
+        <p:txBody>
+          <a:bodyPr wrap="none">
+            <a:spAutoFit/>
+          </a:bodyPr>
+          <a:lstStyle/>
+          <a:p>
+            <a:pPr>
+              <a:defRPr sz="2000"/>
+            </a:pPr>
+            <a:r>
+              <a:t>Considerations:</a:t>
             </a:r>
           </a:p>
         </p:txBody>
       </p:sp>
     </p:spTree>
-    <p:extLst>
-      <p:ext uri="{BB962C8B-B14F-4D97-AF65-F5344CB8AC3E}">
-        <p14:creationId xmlns:p14="http://schemas.microsoft.com/office/powerpoint/2010/main" val="432402450"/>
-      </p:ext>
-    </p:extLst>
+  </p:cSld>
+  <p:clrMapOvr>
+    <a:masterClrMapping/>
+  </p:clrMapOvr>
+</p:sld>
+</file>
+
+<file path=ppt/slides/slide2.xml><?xml version="1.0" encoding="utf-8"?>
+<p:sld xmlns:a="http://schemas.openxmlformats.org/drawingml/2006/main" xmlns:p="http://schemas.openxmlformats.org/presentationml/2006/main" xmlns:r="http://schemas.openxmlformats.org/officeDocument/2006/relationships">
+  <p:cSld>
+    <p:spTree>
+      <p:nvGrpSpPr>
+        <p:cNvPr id="1" name=""/>
+        <p:cNvGrpSpPr/>
+        <p:nvPr/>
+      </p:nvGrpSpPr>
+      <p:grpSpPr/>
+      <p:grpSp>
+        <p:nvGrpSpPr>
+          <p:cNvPr id="4" name="Group 3"/>
+          <p:cNvGrpSpPr/>
+          <p:nvPr/>
+        </p:nvGrpSpPr>
+        <p:grpSpPr>
+          <a:xfrm>
+            <a:off x="914400" y="914400"/>
+            <a:ext cx="3657600" cy="1371600"/>
+            <a:chOff x="914400" y="914400"/>
+            <a:chExt cx="3657600" cy="1371600"/>
+          </a:xfrm>
+        </p:grpSpPr>
+        <p:sp>
+          <p:nvSpPr>
+            <p:cNvPr id="2" name="TextBox 1"/>
+            <p:cNvSpPr txBox="1"/>
+            <p:nvPr/>
+          </p:nvSpPr>
+          <p:spPr>
+            <a:xfrm>
+              <a:off x="914400" y="1828800"/>
+              <a:ext cx="3657600" cy="457200"/>
+            </a:xfrm>
+            <a:prstGeom prst="rect">
+              <a:avLst/>
+            </a:prstGeom>
+            <a:noFill/>
+          </p:spPr>
+          <p:txBody>
+            <a:bodyPr wrap="none">
+              <a:spAutoFit/>
+            </a:bodyPr>
+            <a:lstStyle/>
+            <a:p>
+              <a:r>
+                <a:t>Lower grouped textbox</a:t>
+              </a:r>
+            </a:p>
+          </p:txBody>
+        </p:sp>
+        <p:sp>
+          <p:nvSpPr>
+            <p:cNvPr id="3" name="TextBox 2"/>
+            <p:cNvSpPr txBox="1"/>
+            <p:nvPr/>
+          </p:nvSpPr>
+          <p:spPr>
+            <a:xfrm>
+              <a:off x="914400" y="914400"/>
+              <a:ext cx="3657600" cy="457200"/>
+            </a:xfrm>
+            <a:prstGeom prst="rect">
+              <a:avLst/>
+            </a:prstGeom>
+            <a:noFill/>
+          </p:spPr>
+          <p:txBody>
+            <a:bodyPr wrap="none">
+              <a:spAutoFit/>
+            </a:bodyPr>
+            <a:lstStyle/>
+            <a:p>
+              <a:r>
+                <a:t>Upper grouped textbox</a:t>
+              </a:r>
+            </a:p>
+          </p:txBody>
+        </p:sp>
+      </p:grpSp>
+    </p:spTree>
   </p:cSld>
   <p:clrMapOvr>
     <a:masterClrMapping/>
@@ -3469,44 +3372,44 @@
         <a:sysClr val="window" lastClr="FFFFFF"/>
       </a:lt1>
       <a:dk2>
-        <a:srgbClr val="0E2841"/>
+        <a:srgbClr val="1F497D"/>
       </a:dk2>
       <a:lt2>
-        <a:srgbClr val="E8E8E8"/>
+        <a:srgbClr val="EEECE1"/>
       </a:lt2>
       <a:accent1>
-        <a:srgbClr val="156082"/>
+        <a:srgbClr val="4F81BD"/>
       </a:accent1>
       <a:accent2>
-        <a:srgbClr val="E97132"/>
+        <a:srgbClr val="C0504D"/>
       </a:accent2>
       <a:accent3>
-        <a:srgbClr val="196B24"/>
+        <a:srgbClr val="9BBB59"/>
       </a:accent3>
       <a:accent4>
-        <a:srgbClr val="0F9ED5"/>
+        <a:srgbClr val="8064A2"/>
       </a:accent4>
       <a:accent5>
-        <a:srgbClr val="A02B93"/>
+        <a:srgbClr val="4BACC6"/>
       </a:accent5>
       <a:accent6>
-        <a:srgbClr val="4EA72E"/>
+        <a:srgbClr val="F79646"/>
       </a:accent6>
       <a:hlink>
-        <a:srgbClr val="467886"/>
+        <a:srgbClr val="0000FF"/>
       </a:hlink>
       <a:folHlink>
-        <a:srgbClr val="96607D"/>
+        <a:srgbClr val="800080"/>
       </a:folHlink>
     </a:clrScheme>
     <a:fontScheme name="Office">
       <a:majorFont>
-        <a:latin typeface="Aptos Display" panose="02110004020202020204"/>
+        <a:latin typeface="Calibri"/>
         <a:ea typeface=""/>
         <a:cs typeface=""/>
-        <a:font script="Jpan" typeface="游ゴシック Light"/>
+        <a:font script="Jpan" typeface="ＭＳ Ｐゴシック"/>
         <a:font script="Hang" typeface="맑은 고딕"/>
-        <a:font script="Hans" typeface="等线 Light"/>
+        <a:font script="Hans" typeface="宋体"/>
         <a:font script="Hant" typeface="新細明體"/>
         <a:font script="Arab" typeface="Times New Roman"/>
         <a:font script="Hebr" typeface="Times New Roman"/>
@@ -3534,31 +3437,14 @@
         <a:font script="Viet" typeface="Times New Roman"/>
         <a:font script="Uigh" typeface="Microsoft Uighur"/>
         <a:font script="Geor" typeface="Sylfaen"/>
-        <a:font script="Armn" typeface="Arial"/>
-        <a:font script="Bugi" typeface="Leelawadee UI"/>
-        <a:font script="Bopo" typeface="Microsoft JhengHei"/>
-        <a:font script="Java" typeface="Javanese Text"/>
-        <a:font script="Lisu" typeface="Segoe UI"/>
-        <a:font script="Mymr" typeface="Myanmar Text"/>
-        <a:font script="Nkoo" typeface="Ebrima"/>
-        <a:font script="Olck" typeface="Nirmala UI"/>
-        <a:font script="Osma" typeface="Ebrima"/>
-        <a:font script="Phag" typeface="Phagspa"/>
-        <a:font script="Syrn" typeface="Estrangelo Edessa"/>
-        <a:font script="Syrj" typeface="Estrangelo Edessa"/>
-        <a:font script="Syre" typeface="Estrangelo Edessa"/>
-        <a:font script="Sora" typeface="Nirmala UI"/>
-        <a:font script="Tale" typeface="Microsoft Tai Le"/>
-        <a:font script="Talu" typeface="Microsoft New Tai Lue"/>
-        <a:font script="Tfng" typeface="Ebrima"/>
       </a:majorFont>
       <a:minorFont>
-        <a:latin typeface="Aptos" panose="02110004020202020204"/>
+        <a:latin typeface="Calibri"/>
         <a:ea typeface=""/>
         <a:cs typeface=""/>
-        <a:font script="Jpan" typeface="游ゴシック"/>
+        <a:font script="Jpan" typeface="ＭＳ Ｐゴシック"/>
         <a:font script="Hang" typeface="맑은 고딕"/>
-        <a:font script="Hans" typeface="等线"/>
+        <a:font script="Hans" typeface="宋体"/>
         <a:font script="Hant" typeface="新細明體"/>
         <a:font script="Arab" typeface="Arial"/>
         <a:font script="Hebr" typeface="Arial"/>
@@ -3586,23 +3472,6 @@
         <a:font script="Viet" typeface="Arial"/>
         <a:font script="Uigh" typeface="Microsoft Uighur"/>
         <a:font script="Geor" typeface="Sylfaen"/>
-        <a:font script="Armn" typeface="Arial"/>
-        <a:font script="Bugi" typeface="Leelawadee UI"/>
-        <a:font script="Bopo" typeface="Microsoft JhengHei"/>
-        <a:font script="Java" typeface="Javanese Text"/>
-        <a:font script="Lisu" typeface="Segoe UI"/>
-        <a:font script="Mymr" typeface="Myanmar Text"/>
-        <a:font script="Nkoo" typeface="Ebrima"/>
-        <a:font script="Olck" typeface="Nirmala UI"/>
-        <a:font script="Osma" typeface="Ebrima"/>
-        <a:font script="Phag" typeface="Phagspa"/>
-        <a:font script="Syrn" typeface="Estrangelo Edessa"/>
-        <a:font script="Syrj" typeface="Estrangelo Edessa"/>
-        <a:font script="Syre" typeface="Estrangelo Edessa"/>
-        <a:font script="Sora" typeface="Nirmala UI"/>
-        <a:font script="Tale" typeface="Microsoft Tai Le"/>
-        <a:font script="Talu" typeface="Microsoft New Tai Lue"/>
-        <a:font script="Tfng" typeface="Ebrima"/>
       </a:minorFont>
     </a:fontScheme>
     <a:fmtScheme name="Office">
@@ -3614,136 +3483,180 @@
           <a:gsLst>
             <a:gs pos="0">
               <a:schemeClr val="phClr">
-                <a:lumMod val="110000"/>
-                <a:satMod val="105000"/>
-                <a:tint val="67000"/>
+                <a:tint val="50000"/>
+                <a:satMod val="300000"/>
               </a:schemeClr>
             </a:gs>
-            <a:gs pos="50000">
+            <a:gs pos="35000">
               <a:schemeClr val="phClr">
-                <a:lumMod val="105000"/>
-                <a:satMod val="103000"/>
-                <a:tint val="73000"/>
+                <a:tint val="37000"/>
+                <a:satMod val="300000"/>
               </a:schemeClr>
             </a:gs>
             <a:gs pos="100000">
               <a:schemeClr val="phClr">
-                <a:lumMod val="105000"/>
-                <a:satMod val="109000"/>
-                <a:tint val="81000"/>
+                <a:tint val="15000"/>
+                <a:satMod val="350000"/>
               </a:schemeClr>
             </a:gs>
           </a:gsLst>
-          <a:lin ang="5400000" scaled="0"/>
+          <a:lin ang="16200000" scaled="1"/>
         </a:gradFill>
         <a:gradFill rotWithShape="1">
           <a:gsLst>
             <a:gs pos="0">
               <a:schemeClr val="phClr">
-                <a:satMod val="103000"/>
-                <a:lumMod val="102000"/>
-                <a:tint val="94000"/>
-              </a:schemeClr>
-            </a:gs>
-            <a:gs pos="50000">
-              <a:schemeClr val="phClr">
-                <a:satMod val="110000"/>
-                <a:lumMod val="100000"/>
+                <a:tint val="100000"/>
                 <a:shade val="100000"/>
+                <a:satMod val="130000"/>
               </a:schemeClr>
             </a:gs>
             <a:gs pos="100000">
               <a:schemeClr val="phClr">
-                <a:lumMod val="99000"/>
-                <a:satMod val="120000"/>
-                <a:shade val="78000"/>
+                <a:tint val="50000"/>
+                <a:shade val="100000"/>
+                <a:satMod val="350000"/>
               </a:schemeClr>
             </a:gs>
           </a:gsLst>
-          <a:lin ang="5400000" scaled="0"/>
+          <a:lin ang="16200000" scaled="0"/>
         </a:gradFill>
       </a:fillStyleLst>
       <a:lnStyleLst>
-        <a:ln w="12700" cap="flat" cmpd="sng" algn="ctr">
+        <a:ln w="9525" cap="flat" cmpd="sng" algn="ctr">
           <a:solidFill>
-            <a:schemeClr val="phClr"/>
+            <a:schemeClr val="phClr">
+              <a:shade val="95000"/>
+              <a:satMod val="105000"/>
+            </a:schemeClr>
           </a:solidFill>
           <a:prstDash val="solid"/>
-          <a:miter lim="800000"/>
-        </a:ln>
-        <a:ln w="19050" cap="flat" cmpd="sng" algn="ctr">
-          <a:solidFill>
-            <a:schemeClr val="phClr"/>
-          </a:solidFill>
-          <a:prstDash val="solid"/>
-          <a:miter lim="800000"/>
         </a:ln>
         <a:ln w="25400" cap="flat" cmpd="sng" algn="ctr">
           <a:solidFill>
             <a:schemeClr val="phClr"/>
           </a:solidFill>
           <a:prstDash val="solid"/>
-          <a:miter lim="800000"/>
+        </a:ln>
+        <a:ln w="38100" cap="flat" cmpd="sng" algn="ctr">
+          <a:solidFill>
+            <a:schemeClr val="phClr"/>
+          </a:solidFill>
+          <a:prstDash val="solid"/>
         </a:ln>
       </a:lnStyleLst>
       <a:effectStyleLst>
         <a:effectStyle>
-          <a:effectLst/>
-        </a:effectStyle>
-        <a:effectStyle>
-          <a:effectLst/>
+          <a:effectLst>
+            <a:outerShdw blurRad="40000" dist="20000" dir="5400000" rotWithShape="0">
+              <a:srgbClr val="000000">
+                <a:alpha val="38000"/>
+              </a:srgbClr>
+            </a:outerShdw>
+          </a:effectLst>
         </a:effectStyle>
         <a:effectStyle>
           <a:effectLst>
-            <a:outerShdw blurRad="57150" dist="19050" dir="5400000" algn="ctr" rotWithShape="0">
+            <a:outerShdw blurRad="40000" dist="23000" dir="5400000" rotWithShape="0">
               <a:srgbClr val="000000">
-                <a:alpha val="63000"/>
+                <a:alpha val="35000"/>
               </a:srgbClr>
             </a:outerShdw>
           </a:effectLst>
+        </a:effectStyle>
+        <a:effectStyle>
+          <a:effectLst>
+            <a:outerShdw blurRad="40000" dist="23000" dir="5400000" rotWithShape="0">
+              <a:srgbClr val="000000">
+                <a:alpha val="35000"/>
+              </a:srgbClr>
+            </a:outerShdw>
+          </a:effectLst>
+          <a:scene3d>
+            <a:camera prst="orthographicFront">
+              <a:rot lat="0" lon="0" rev="0"/>
+            </a:camera>
+            <a:lightRig rig="threePt" dir="t">
+              <a:rot lat="0" lon="0" rev="1200000"/>
+            </a:lightRig>
+          </a:scene3d>
+          <a:sp3d>
+            <a:bevelT w="63500" h="25400"/>
+          </a:sp3d>
         </a:effectStyle>
       </a:effectStyleLst>
       <a:bgFillStyleLst>
         <a:solidFill>
           <a:schemeClr val="phClr"/>
         </a:solidFill>
-        <a:solidFill>
-          <a:schemeClr val="phClr">
-            <a:tint val="95000"/>
-            <a:satMod val="170000"/>
-          </a:schemeClr>
-        </a:solidFill>
         <a:gradFill rotWithShape="1">
           <a:gsLst>
             <a:gs pos="0">
               <a:schemeClr val="phClr">
-                <a:tint val="93000"/>
-                <a:satMod val="150000"/>
-                <a:shade val="98000"/>
-                <a:lumMod val="102000"/>
+                <a:tint val="40000"/>
+                <a:satMod val="350000"/>
               </a:schemeClr>
             </a:gs>
-            <a:gs pos="50000">
+            <a:gs pos="40000">
               <a:schemeClr val="phClr">
-                <a:tint val="98000"/>
-                <a:satMod val="130000"/>
-                <a:shade val="90000"/>
-                <a:lumMod val="103000"/>
+                <a:tint val="45000"/>
+                <a:shade val="99000"/>
+                <a:satMod val="350000"/>
               </a:schemeClr>
             </a:gs>
             <a:gs pos="100000">
               <a:schemeClr val="phClr">
-                <a:shade val="63000"/>
-                <a:satMod val="120000"/>
+                <a:shade val="20000"/>
+                <a:satMod val="255000"/>
               </a:schemeClr>
             </a:gs>
           </a:gsLst>
-          <a:lin ang="5400000" scaled="0"/>
+          <a:path path="circle">
+            <a:fillToRect l="50000" t="-80000" r="50000" b="180000"/>
+          </a:path>
+        </a:gradFill>
+        <a:gradFill rotWithShape="1">
+          <a:gsLst>
+            <a:gs pos="0">
+              <a:schemeClr val="phClr">
+                <a:tint val="80000"/>
+                <a:satMod val="300000"/>
+              </a:schemeClr>
+            </a:gs>
+            <a:gs pos="100000">
+              <a:schemeClr val="phClr">
+                <a:shade val="30000"/>
+                <a:satMod val="200000"/>
+              </a:schemeClr>
+            </a:gs>
+          </a:gsLst>
+          <a:path path="circle">
+            <a:fillToRect l="50000" t="50000" r="50000" b="50000"/>
+          </a:path>
         </a:gradFill>
       </a:bgFillStyleLst>
     </a:fmtScheme>
   </a:themeElements>
   <a:objectDefaults>
+    <a:spDef>
+      <a:spPr/>
+      <a:bodyPr/>
+      <a:lstStyle/>
+      <a:style>
+        <a:lnRef idx="1">
+          <a:schemeClr val="accent1"/>
+        </a:lnRef>
+        <a:fillRef idx="3">
+          <a:schemeClr val="accent1"/>
+        </a:fillRef>
+        <a:effectRef idx="2">
+          <a:schemeClr val="accent1"/>
+        </a:effectRef>
+        <a:fontRef idx="minor">
+          <a:schemeClr val="lt1"/>
+        </a:fontRef>
+      </a:style>
+    </a:spDef>
     <a:lnDef>
       <a:spPr/>
       <a:bodyPr/>
@@ -3765,10 +3678,5 @@
     </a:lnDef>
   </a:objectDefaults>
   <a:extraClrSchemeLst/>
-  <a:extLst>
-    <a:ext uri="{05A4C25C-085E-4340-85A3-A5531E510DB2}">
-      <thm15:themeFamily xmlns:thm15="http://schemas.microsoft.com/office/thememl/2012/main" name="Office Theme" id="{2E142A2C-CD16-42D6-873A-C26D2A0506FA}" vid="{1BDDFF52-6CD6-40A5-AB3C-68EB2F1E4D0A}"/>
-    </a:ext>
-  </a:extLst>
 </a:theme>
 </file>
</xml_diff>